<commit_message>
feat(presentation): switch to light theme and problem-first introduction
</commit_message>
<xml_diff>
--- a/SolarSchoolsUSA_PitchDeck.pptx
+++ b/SolarSchoolsUSA_PitchDeck.pptx
@@ -511,7 +511,7 @@
           <a:lstStyle/>
           <a:p>
             <a:r>
-              <a:t>[0:00 - 0:25] 'Hi everyone, my name is Pranav Balaji, and I am a 10th grader. Every single morning when we arrive at school, our parking lots sit empty under the blazing sun. At the same time, our school districts spend millions of dollars every year on electric bills. Today I want to show you SolarSchools USA: a web platform I built so any student or school board member can map their school parking lot, calculate solar energy, and download a ready-to-use board proposal in just 10 seconds.'</a:t>
+              <a:t>[0:00 - 0:25] 'Hi everyone, my name is Pranav Balaji, and I am a 10th grader. I want to start with a simple question: why are our school parking lots baking under the sun, while our districts bleed billions on power? Every single morning, our cars sit on 140-degree asphalt. Meanwhile, public schools spend 8 billion dollars every year on electricity bills! And the craziest part? The federal government now offers cash checks covering up to 50% of solar canopy costs, but over 90% of school boards have never heard of it. That is the exact problem we are solving with SolarSchools USA.'</a:t>
             </a:r>
           </a:p>
         </p:txBody>
@@ -651,7 +651,7 @@
           <a:lstStyle/>
           <a:p>
             <a:r>
-              <a:t>[0:25 - 0:50] 'Think about what school feels like in August or September. Our parking lots are black asphalt that reaches 140 degrees. Cars turn into ovens, and playgrounds bake. Meanwhile, public schools across the country spend over 8 billion dollars every year on electric bills. Electricity is the second-largest bill a school district pays, right after teacher salaries! And when school boards try to fix this, private consultants charge up to $25,000 just to do an initial study. Most schools give up before they even start.'</a:t>
+              <a:t>[0:25 - 0:50] 'Why hasn't every school built solar canopies already? Two reasons. First, because public schools don't pay taxes, they historically couldn't use solar tax credits. Second, private engineering consultants charge $25,000 just to do a feasibility study! Most public school districts simply don't have that cash lying around. So they wait. But every year a typical high school delays, they lose $140,000 to the utility company. That is two full-time teacher salaries lost every single year.'</a:t>
             </a:r>
           </a:p>
         </p:txBody>
@@ -721,7 +721,7 @@
           <a:lstStyle/>
           <a:p>
             <a:r>
-              <a:t>[0:50 - 1:15] 'Here is the exciting part that almost nobody knows. In 2022, a new federal law called 'Direct Pay' was passed. Historically, public schools couldn't get solar tax credits because schools don't pay taxes. Now, under Section 6417, the IRS will literally write an actual CASH check directly to public school districts! They pay a 30% base grant, plus an extra 10% for American steel and 10% for Title I schools. That means the federal government can cover up to 50% of the entire solar canopy! The problem? Over 90% of school boards have no idea this money exists.'</a:t>
+              <a:t>[0:50 - 1:15] 'Here is the breakthrough. In 2022, Congress passed a new law called 'Direct Pay' under Section 6417. For the first time in history, the IRS writes an actual, uncapped CASH reimbursement check directly to public schools! They pay a 30% base grant, plus an extra 10% for American steel and 10% for Title I schools. That means the federal government covers up to 50% of the entire project! All the district has to do is claim it. But almost no school board knows how.'</a:t>
             </a:r>
           </a:p>
         </p:txBody>
@@ -791,7 +791,7 @@
           <a:lstStyle/>
           <a:p>
             <a:r>
-              <a:t>[1:15 - 1:40] 'So I decided to build a solution: SolarSchools USA. It is a web application designed so any high school student or parent can use it. Step 1: you select your school from our database of 18 Bay Area campuses. It zooms right onto the parking lot. Step 2: in real time, it connects to the Department of Energy's solar engine and calculates how many panels fit, how much electricity they generate, and how much money the school saves. Step 3: with one click, you download a complete School Board Action Brief with the exact financial breakdown and a template resolution ready to present to school board trustees.'</a:t>
+              <a:t>[1:15 - 1:40] 'So I built SolarSchools USA to democratize this data. Step 1: choose any campus from our 18 Bay Area pilot schools. It zooms right onto the parking lot. Step 2: it runs live Department of Energy solar physics in real time to calculate panel count, kilowatt capacity, and power output. Step 3: click one button, and you get an executive action brief with a 25-year cashflow schedule and a draft board resolution. Any student can hand this directly to their school board trustees.'</a:t>
             </a:r>
           </a:p>
         </p:txBody>
@@ -861,7 +861,7 @@
           <a:lstStyle/>
           <a:p>
             <a:r>
-              <a:t>[1:40 - 2:05] 'We made sure the numbers are rock-solid. We don't assume the entire parking lot is covered in solar. We use an empirical 65% coverage factor, which reserves 24-foot driving aisles, ADA handicap spots, and a full 14-foot vertical clearance for yellow school buses. Then, we connect directly to the Department of Energy's NREL database to pull exact satellite sunshine numbers for the school's precise coordinates, accounting for summer heat, dust, and winter sun angles. It's the same math that professional engineering firms use, but packaged so anyone can run it in seconds.'</a:t>
+              <a:t>[1:40 - 2:05] 'We made sure the numbers are rock-solid. We don't assume the entire parking lot is covered in solar. We apply an empirical 65% packing factor, which reserves driving lanes, ADA spots, and a 14-foot vertical clearance for yellow school buses. Then, we query the Department of Energy's satellite database to calculate exact sunshine, temperature derates, and seasonal loss. It's the same math that engineering firms use, but packaged so anyone can run it in seconds.'</a:t>
             </a:r>
           </a:p>
         </p:txBody>
@@ -931,7 +931,7 @@
           <a:lstStyle/>
           <a:p>
             <a:r>
-              <a:t>[2:05 - 2:35] 'Let's look at real-world proof right here in Silicon Valley. At Monta Vista High in Cupertino, they installed 550 kW of solar carports in 2021. Our software modeled that they would save $145,000 a year. When we checked the district's actual published utility bills, they saved $139,200. That's a 4% match with real life! Now look just 10 miles away at Palo Alto High. They have a massive parking lot baking in the sun, paying $140,000 a year to the power company that they don't need to pay. And there is a $754,000 cash grant from the federal government waiting for them. That $140,000 every year could pay for two full-time teachers or hundreds of laptops!'</a:t>
+              <a:t>[2:05 - 2:35] 'Look at real proof right here in Silicon Valley. At Monta Vista High in Cupertino, they installed solar carports in 2021. Our software modeled $145,000 in annual savings. Their actual published bills showed $139,200—within 4%! Now look 10 miles away at Palo Alto High. They have a massive unshaded parking lot losing $140,000 every year. And there is a $754,000 check from the federal government sitting on the table unclaimed. That $140,000 lost every single year could hire two full-time teachers!'</a:t>
             </a:r>
           </a:p>
         </p:txBody>
@@ -1001,7 +1001,7 @@
           <a:lstStyle/>
           <a:p>
             <a:r>
-              <a:t>[2:35 - 3:00] 'When you look at the financials, it's an absolute no-brainer. Normally, a solar canopy might take 6 to 7 years to pay back. With the federal Direct Pay check covering up to 40% or 50% upfront, the payback period drops to just 3.7 years! After year four, all that electricity is pure profit for the school district. Over the 25-year lifespan of the panels, even after paying for washing and maintenance, a single high school generates nearly 10 million dollars in net savings. That's permanent money for science labs, clubs, and teachers without raising local property taxes.'</a:t>
+              <a:t>[2:35 - 3:00] 'When you look at the economics, it is an absolute no-brainer. With the federal Direct Pay check covering up to 40% or 50% upfront, the payback period drops to just 3.7 years! After year four, all that electricity is pure savings for the school district. Over the 25-year lifespan of the panels, a single high school generates nearly 10 million dollars in net savings. That is permanent money for teachers, science labs, and student mental health counselors.'</a:t>
             </a:r>
           </a:p>
         </p:txBody>
@@ -4162,7 +4162,7 @@
             <a:avLst/>
           </a:prstGeom>
           <a:solidFill>
-            <a:srgbClr val="0B0F19"/>
+            <a:srgbClr val="F8FAFC"/>
           </a:solidFill>
           <a:ln>
             <a:noFill/>
@@ -4205,10 +4205,12 @@
             <a:avLst/>
           </a:prstGeom>
           <a:solidFill>
-            <a:srgbClr val="0F172A"/>
+            <a:srgbClr val="F1F5F9"/>
           </a:solidFill>
-          <a:ln>
-            <a:noFill/>
+          <a:ln w="12700">
+            <a:solidFill>
+              <a:srgbClr val="E2E8F0"/>
+            </a:solidFill>
           </a:ln>
         </p:spPr>
         <p:style>
@@ -4310,7 +4312,7 @@
             <a:pPr>
               <a:defRPr sz="950">
                 <a:solidFill>
-                  <a:srgbClr val="A0AEC0"/>
+                  <a:srgbClr val="475569"/>
                 </a:solidFill>
               </a:defRPr>
             </a:pPr>
@@ -4345,7 +4347,7 @@
             <a:pPr algn="r">
               <a:defRPr sz="1000" b="1">
                 <a:solidFill>
-                  <a:srgbClr val="38BDF8"/>
+                  <a:srgbClr val="0284C7"/>
                 </a:solidFill>
               </a:defRPr>
             </a:pPr>
@@ -4370,7 +4372,7 @@
             <a:avLst/>
           </a:prstGeom>
           <a:solidFill>
-            <a:srgbClr val="38BDF8"/>
+            <a:srgbClr val="0284C7"/>
           </a:solidFill>
           <a:ln>
             <a:noFill/>
@@ -4406,8 +4408,8 @@
         </p:nvSpPr>
         <p:spPr>
           <a:xfrm>
-            <a:off x="731520" y="1188720"/>
-            <a:ext cx="10698480" cy="2286000"/>
+            <a:off x="731520" y="1051560"/>
+            <a:ext cx="10698480" cy="2103120"/>
           </a:xfrm>
           <a:prstGeom prst="rect">
             <a:avLst/>
@@ -4423,42 +4425,27 @@
             <a:pPr>
               <a:defRPr sz="1000" b="1">
                 <a:solidFill>
-                  <a:srgbClr val="38BDF8"/>
-                </a:solidFill>
-              </a:defRPr>
-            </a:pPr>
-            <a:r>
-              <a:t>SVYCA YOUTH FOR EARTH HACKATHON</a:t>
-            </a:r>
-          </a:p>
-          <a:p>
-            <a:pPr>
-              <a:spcBef>
-                <a:spcPts val="400"/>
-              </a:spcBef>
-              <a:defRPr sz="4400" b="1">
-                <a:solidFill>
-                  <a:srgbClr val="F8FAFC"/>
-                </a:solidFill>
-              </a:defRPr>
-            </a:pPr>
-            <a:r>
-              <a:t>SolarSchools USA</a:t>
-            </a:r>
-          </a:p>
-          <a:p>
-            <a:pPr>
-              <a:spcBef>
-                <a:spcPts val="400"/>
-              </a:spcBef>
-              <a:defRPr sz="1800" b="1">
-                <a:solidFill>
-                  <a:srgbClr val="10B981"/>
-                </a:solidFill>
-              </a:defRPr>
-            </a:pPr>
-            <a:r>
-              <a:t>Turning School Parking Lots into Clean Energy &amp; Classroom Cash</a:t>
+                  <a:srgbClr val="8C1515"/>
+                </a:solidFill>
+              </a:defRPr>
+            </a:pPr>
+            <a:r>
+              <a:t>SOLARSCHOOLS USA  |  SVYCA YOUTH FOR EARTH HACKATHON</a:t>
+            </a:r>
+          </a:p>
+          <a:p>
+            <a:pPr>
+              <a:spcBef>
+                <a:spcPts val="300"/>
+              </a:spcBef>
+              <a:defRPr sz="2600" b="1">
+                <a:solidFill>
+                  <a:srgbClr val="0F172A"/>
+                </a:solidFill>
+              </a:defRPr>
+            </a:pPr>
+            <a:r>
+              <a:t>The Problem: Why Are School Parking Lots Baking in the Sun While Districts Bleed Billions on Power?</a:t>
             </a:r>
           </a:p>
           <a:p>
@@ -4468,12 +4455,12 @@
               </a:spcBef>
               <a:defRPr sz="1200">
                 <a:solidFill>
-                  <a:srgbClr val="A0AEC0"/>
-                </a:solidFill>
-              </a:defRPr>
-            </a:pPr>
-            <a:r>
-              <a:t>A simple platform helping students, teachers, and school boards claim federal solar funding in seconds.</a:t>
+                  <a:srgbClr val="475569"/>
+                </a:solidFill>
+              </a:defRPr>
+            </a:pPr>
+            <a:r>
+              <a:t>Across the U.S., 100,000 public schools sit on unshaded blacktop asphalt, surrendering classroom funds to utility companies while millions in federal clean energy grants sit unclaimed.</a:t>
             </a:r>
           </a:p>
         </p:txBody>
@@ -4486,8 +4473,8 @@
         </p:nvSpPr>
         <p:spPr>
           <a:xfrm>
-            <a:off x="731520" y="3566160"/>
-            <a:ext cx="10698480" cy="411480"/>
+            <a:off x="731520" y="3291840"/>
+            <a:ext cx="10698480" cy="365760"/>
           </a:xfrm>
           <a:prstGeom prst="rect">
             <a:avLst/>
@@ -4501,9 +4488,9 @@
           <a:lstStyle/>
           <a:p>
             <a:pPr>
-              <a:defRPr sz="1100" b="1">
-                <a:solidFill>
-                  <a:srgbClr val="F8FAFC"/>
+              <a:defRPr sz="1050" b="1">
+                <a:solidFill>
+                  <a:srgbClr val="0F172A"/>
                 </a:solidFill>
               </a:defRPr>
             </a:pPr>
@@ -4521,18 +4508,18 @@
         </p:nvSpPr>
         <p:spPr>
           <a:xfrm>
-            <a:off x="548640" y="4160520"/>
-            <a:ext cx="3474720" cy="2194560"/>
+            <a:off x="548640" y="3886200"/>
+            <a:ext cx="3474720" cy="2468880"/>
           </a:xfrm>
           <a:prstGeom prst="roundRect">
             <a:avLst/>
           </a:prstGeom>
           <a:solidFill>
-            <a:srgbClr val="131A2B"/>
+            <a:srgbClr val="FFFFFF"/>
           </a:solidFill>
           <a:ln w="12700">
             <a:solidFill>
-              <a:srgbClr val="222E4A"/>
+              <a:srgbClr val="E2E8F0"/>
             </a:solidFill>
           </a:ln>
         </p:spPr>
@@ -4566,14 +4553,14 @@
         </p:nvSpPr>
         <p:spPr>
           <a:xfrm>
-            <a:off x="548640" y="4160520"/>
+            <a:off x="548640" y="3886200"/>
             <a:ext cx="3474720" cy="54864"/>
           </a:xfrm>
           <a:prstGeom prst="roundRect">
             <a:avLst/>
           </a:prstGeom>
           <a:solidFill>
-            <a:srgbClr val="38BDF8"/>
+            <a:srgbClr val="DC2626"/>
           </a:solidFill>
           <a:ln>
             <a:noFill/>
@@ -4609,8 +4596,8 @@
         </p:nvSpPr>
         <p:spPr>
           <a:xfrm>
-            <a:off x="731520" y="4270248"/>
-            <a:ext cx="3108960" cy="1975104"/>
+            <a:off x="731520" y="3995928"/>
+            <a:ext cx="3108960" cy="2249424"/>
           </a:xfrm>
           <a:prstGeom prst="rect">
             <a:avLst/>
@@ -4626,72 +4613,72 @@
             <a:pPr>
               <a:defRPr sz="850" b="1">
                 <a:solidFill>
-                  <a:srgbClr val="38BDF8"/>
-                </a:solidFill>
-              </a:defRPr>
-            </a:pPr>
-            <a:r>
-              <a:t>18 LOCAL SCHOOLS MAPPED</a:t>
-            </a:r>
-          </a:p>
-          <a:p>
-            <a:pPr>
-              <a:spcBef>
-                <a:spcPts val="300"/>
-              </a:spcBef>
-              <a:defRPr sz="1200" b="1">
-                <a:solidFill>
-                  <a:srgbClr val="F8FAFC"/>
-                </a:solidFill>
-              </a:defRPr>
-            </a:pPr>
-            <a:r>
-              <a:t>High-Resolution Campus Data</a:t>
-            </a:r>
-          </a:p>
-          <a:p>
-            <a:pPr>
-              <a:spcBef>
-                <a:spcPts val="300"/>
-              </a:spcBef>
-              <a:defRPr sz="950">
-                <a:solidFill>
-                  <a:srgbClr val="A0AEC0"/>
-                </a:solidFill>
-              </a:defRPr>
-            </a:pPr>
-            <a:r>
-              <a:t>- High, Middle &amp; Elementary schools mapped</a:t>
-            </a:r>
-          </a:p>
-          <a:p>
-            <a:pPr>
-              <a:spcBef>
-                <a:spcPts val="300"/>
-              </a:spcBef>
-              <a:defRPr sz="950">
-                <a:solidFill>
-                  <a:srgbClr val="A0AEC0"/>
-                </a:solidFill>
-              </a:defRPr>
-            </a:pPr>
-            <a:r>
-              <a:t>- Exact parking lots ground-truthed on satellite</a:t>
-            </a:r>
-          </a:p>
-          <a:p>
-            <a:pPr>
-              <a:spcBef>
-                <a:spcPts val="300"/>
-              </a:spcBef>
-              <a:defRPr sz="950">
-                <a:solidFill>
-                  <a:srgbClr val="A0AEC0"/>
-                </a:solidFill>
-              </a:defRPr>
-            </a:pPr>
-            <a:r>
-              <a:t>- Zero manual measuring needed</a:t>
+                  <a:srgbClr val="DC2626"/>
+                </a:solidFill>
+              </a:defRPr>
+            </a:pPr>
+            <a:r>
+              <a:t>PROBLEM 1: EXTREME HEAT</a:t>
+            </a:r>
+          </a:p>
+          <a:p>
+            <a:pPr>
+              <a:spcBef>
+                <a:spcPts val="200"/>
+              </a:spcBef>
+              <a:defRPr sz="1500" b="1">
+                <a:solidFill>
+                  <a:srgbClr val="0F172A"/>
+                </a:solidFill>
+              </a:defRPr>
+            </a:pPr>
+            <a:r>
+              <a:t>140°F Baking Asphalt</a:t>
+            </a:r>
+          </a:p>
+          <a:p>
+            <a:pPr>
+              <a:spcBef>
+                <a:spcPts val="400"/>
+              </a:spcBef>
+              <a:defRPr sz="1000">
+                <a:solidFill>
+                  <a:srgbClr val="475569"/>
+                </a:solidFill>
+              </a:defRPr>
+            </a:pPr>
+            <a:r>
+              <a:t>- Empty blacktop bakes student and staff cars</a:t>
+            </a:r>
+          </a:p>
+          <a:p>
+            <a:pPr>
+              <a:spcBef>
+                <a:spcPts val="400"/>
+              </a:spcBef>
+              <a:defRPr sz="1000">
+                <a:solidFill>
+                  <a:srgbClr val="475569"/>
+                </a:solidFill>
+              </a:defRPr>
+            </a:pPr>
+            <a:r>
+              <a:t>- Creates campus heat islands in hot months</a:t>
+            </a:r>
+          </a:p>
+          <a:p>
+            <a:pPr>
+              <a:spcBef>
+                <a:spcPts val="400"/>
+              </a:spcBef>
+              <a:defRPr sz="1000">
+                <a:solidFill>
+                  <a:srgbClr val="475569"/>
+                </a:solidFill>
+              </a:defRPr>
+            </a:pPr>
+            <a:r>
+              <a:t>- Playground asphalt gets too hot for students</a:t>
             </a:r>
           </a:p>
         </p:txBody>
@@ -4704,18 +4691,18 @@
         </p:nvSpPr>
         <p:spPr>
           <a:xfrm>
-            <a:off x="4343400" y="4160520"/>
-            <a:ext cx="3474720" cy="2194560"/>
+            <a:off x="4343400" y="3886200"/>
+            <a:ext cx="3474720" cy="2468880"/>
           </a:xfrm>
           <a:prstGeom prst="roundRect">
             <a:avLst/>
           </a:prstGeom>
           <a:solidFill>
-            <a:srgbClr val="131A2B"/>
+            <a:srgbClr val="FFFFFF"/>
           </a:solidFill>
           <a:ln w="12700">
             <a:solidFill>
-              <a:srgbClr val="222E4A"/>
+              <a:srgbClr val="E2E8F0"/>
             </a:solidFill>
           </a:ln>
         </p:spPr>
@@ -4749,14 +4736,14 @@
         </p:nvSpPr>
         <p:spPr>
           <a:xfrm>
-            <a:off x="4343400" y="4160520"/>
+            <a:off x="4343400" y="3886200"/>
             <a:ext cx="3474720" cy="54864"/>
           </a:xfrm>
           <a:prstGeom prst="roundRect">
             <a:avLst/>
           </a:prstGeom>
           <a:solidFill>
-            <a:srgbClr val="10B981"/>
+            <a:srgbClr val="DC2626"/>
           </a:solidFill>
           <a:ln>
             <a:noFill/>
@@ -4792,8 +4779,8 @@
         </p:nvSpPr>
         <p:spPr>
           <a:xfrm>
-            <a:off x="4526280" y="4270248"/>
-            <a:ext cx="3108960" cy="1975104"/>
+            <a:off x="4526280" y="3995928"/>
+            <a:ext cx="3108960" cy="2249424"/>
           </a:xfrm>
           <a:prstGeom prst="rect">
             <a:avLst/>
@@ -4809,72 +4796,72 @@
             <a:pPr>
               <a:defRPr sz="850" b="1">
                 <a:solidFill>
-                  <a:srgbClr val="10B981"/>
-                </a:solidFill>
-              </a:defRPr>
-            </a:pPr>
-            <a:r>
-              <a:t>REAL SOLAR PHYSICS (NREL)</a:t>
-            </a:r>
-          </a:p>
-          <a:p>
-            <a:pPr>
-              <a:spcBef>
-                <a:spcPts val="300"/>
-              </a:spcBef>
-              <a:defRPr sz="1200" b="1">
-                <a:solidFill>
-                  <a:srgbClr val="F8FAFC"/>
-                </a:solidFill>
-              </a:defRPr>
-            </a:pPr>
-            <a:r>
-              <a:t>Department of Energy Engine</a:t>
-            </a:r>
-          </a:p>
-          <a:p>
-            <a:pPr>
-              <a:spcBef>
-                <a:spcPts val="300"/>
-              </a:spcBef>
-              <a:defRPr sz="950">
-                <a:solidFill>
-                  <a:srgbClr val="A0AEC0"/>
-                </a:solidFill>
-              </a:defRPr>
-            </a:pPr>
-            <a:r>
-              <a:t>- Uses official PVWatts v8 solar calculations</a:t>
-            </a:r>
-          </a:p>
-          <a:p>
-            <a:pPr>
-              <a:spcBef>
-                <a:spcPts val="300"/>
-              </a:spcBef>
-              <a:defRPr sz="950">
-                <a:solidFill>
-                  <a:srgbClr val="A0AEC0"/>
-                </a:solidFill>
-              </a:defRPr>
-            </a:pPr>
-            <a:r>
-              <a:t>- Calculates monthly power generation</a:t>
-            </a:r>
-          </a:p>
-          <a:p>
-            <a:pPr>
-              <a:spcBef>
-                <a:spcPts val="300"/>
-              </a:spcBef>
-              <a:defRPr sz="950">
-                <a:solidFill>
-                  <a:srgbClr val="A0AEC0"/>
-                </a:solidFill>
-              </a:defRPr>
-            </a:pPr>
-            <a:r>
-              <a:t>- Calibrated against active Silicon Valley arrays</a:t>
+                  <a:srgbClr val="DC2626"/>
+                </a:solidFill>
+              </a:defRPr>
+            </a:pPr>
+            <a:r>
+              <a:t>PROBLEM 2: BUDGET DRAIN</a:t>
+            </a:r>
+          </a:p>
+          <a:p>
+            <a:pPr>
+              <a:spcBef>
+                <a:spcPts val="200"/>
+              </a:spcBef>
+              <a:defRPr sz="1500" b="1">
+                <a:solidFill>
+                  <a:srgbClr val="0F172A"/>
+                </a:solidFill>
+              </a:defRPr>
+            </a:pPr>
+            <a:r>
+              <a:t>$8.0 Billion Wasted</a:t>
+            </a:r>
+          </a:p>
+          <a:p>
+            <a:pPr>
+              <a:spcBef>
+                <a:spcPts val="400"/>
+              </a:spcBef>
+              <a:defRPr sz="1000">
+                <a:solidFill>
+                  <a:srgbClr val="475569"/>
+                </a:solidFill>
+              </a:defRPr>
+            </a:pPr>
+            <a:r>
+              <a:t>- Electricity is schools' #2 cost after teachers</a:t>
+            </a:r>
+          </a:p>
+          <a:p>
+            <a:pPr>
+              <a:spcBef>
+                <a:spcPts val="400"/>
+              </a:spcBef>
+              <a:defRPr sz="1000">
+                <a:solidFill>
+                  <a:srgbClr val="475569"/>
+                </a:solidFill>
+              </a:defRPr>
+            </a:pPr>
+            <a:r>
+              <a:t>- Monopoly utility bills drain classroom funds</a:t>
+            </a:r>
+          </a:p>
+          <a:p>
+            <a:pPr>
+              <a:spcBef>
+                <a:spcPts val="400"/>
+              </a:spcBef>
+              <a:defRPr sz="1000">
+                <a:solidFill>
+                  <a:srgbClr val="475569"/>
+                </a:solidFill>
+              </a:defRPr>
+            </a:pPr>
+            <a:r>
+              <a:t>- Schools lose cash that should fund education</a:t>
             </a:r>
           </a:p>
         </p:txBody>
@@ -4887,18 +4874,18 @@
         </p:nvSpPr>
         <p:spPr>
           <a:xfrm>
-            <a:off x="8138160" y="4160520"/>
-            <a:ext cx="3474720" cy="2194560"/>
+            <a:off x="8138160" y="3886200"/>
+            <a:ext cx="3474720" cy="2468880"/>
           </a:xfrm>
           <a:prstGeom prst="roundRect">
             <a:avLst/>
           </a:prstGeom>
           <a:solidFill>
-            <a:srgbClr val="131A2B"/>
+            <a:srgbClr val="FFFFFF"/>
           </a:solidFill>
           <a:ln w="12700">
             <a:solidFill>
-              <a:srgbClr val="222E4A"/>
+              <a:srgbClr val="E2E8F0"/>
             </a:solidFill>
           </a:ln>
         </p:spPr>
@@ -4932,14 +4919,14 @@
         </p:nvSpPr>
         <p:spPr>
           <a:xfrm>
-            <a:off x="8138160" y="4160520"/>
+            <a:off x="8138160" y="3886200"/>
             <a:ext cx="3474720" cy="54864"/>
           </a:xfrm>
           <a:prstGeom prst="roundRect">
             <a:avLst/>
           </a:prstGeom>
           <a:solidFill>
-            <a:srgbClr val="8C1515"/>
+            <a:srgbClr val="D97706"/>
           </a:solidFill>
           <a:ln>
             <a:noFill/>
@@ -4975,8 +4962,8 @@
         </p:nvSpPr>
         <p:spPr>
           <a:xfrm>
-            <a:off x="8321040" y="4270248"/>
-            <a:ext cx="3108960" cy="1975104"/>
+            <a:off x="8321040" y="3995928"/>
+            <a:ext cx="3108960" cy="2249424"/>
           </a:xfrm>
           <a:prstGeom prst="rect">
             <a:avLst/>
@@ -4992,72 +4979,72 @@
             <a:pPr>
               <a:defRPr sz="850" b="1">
                 <a:solidFill>
-                  <a:srgbClr val="8C1515"/>
-                </a:solidFill>
-              </a:defRPr>
-            </a:pPr>
-            <a:r>
-              <a:t>1-CLICK SCHOOL BOARD BRIEF</a:t>
-            </a:r>
-          </a:p>
-          <a:p>
-            <a:pPr>
-              <a:spcBef>
-                <a:spcPts val="300"/>
-              </a:spcBef>
-              <a:defRPr sz="1200" b="1">
-                <a:solidFill>
-                  <a:srgbClr val="F8FAFC"/>
-                </a:solidFill>
-              </a:defRPr>
-            </a:pPr>
-            <a:r>
-              <a:t>Instant Action for Students</a:t>
-            </a:r>
-          </a:p>
-          <a:p>
-            <a:pPr>
-              <a:spcBef>
-                <a:spcPts val="300"/>
-              </a:spcBef>
-              <a:defRPr sz="950">
-                <a:solidFill>
-                  <a:srgbClr val="A0AEC0"/>
-                </a:solidFill>
-              </a:defRPr>
-            </a:pPr>
-            <a:r>
-              <a:t>- Generates 1-page financial summary</a:t>
-            </a:r>
-          </a:p>
-          <a:p>
-            <a:pPr>
-              <a:spcBef>
-                <a:spcPts val="300"/>
-              </a:spcBef>
-              <a:defRPr sz="950">
-                <a:solidFill>
-                  <a:srgbClr val="A0AEC0"/>
-                </a:solidFill>
-              </a:defRPr>
-            </a:pPr>
-            <a:r>
-              <a:t>- Includes ready-to-vote board resolution</a:t>
-            </a:r>
-          </a:p>
-          <a:p>
-            <a:pPr>
-              <a:spcBef>
-                <a:spcPts val="300"/>
-              </a:spcBef>
-              <a:defRPr sz="950">
-                <a:solidFill>
-                  <a:srgbClr val="A0AEC0"/>
-                </a:solidFill>
-              </a:defRPr>
-            </a:pPr>
-            <a:r>
-              <a:t>- Gives students the tools to speak to trustees</a:t>
+                  <a:srgbClr val="D97706"/>
+                </a:solidFill>
+              </a:defRPr>
+            </a:pPr>
+            <a:r>
+              <a:t>PROBLEM 3: THE GAP</a:t>
+            </a:r>
+          </a:p>
+          <a:p>
+            <a:pPr>
+              <a:spcBef>
+                <a:spcPts val="200"/>
+              </a:spcBef>
+              <a:defRPr sz="1500" b="1">
+                <a:solidFill>
+                  <a:srgbClr val="0F172A"/>
+                </a:solidFill>
+              </a:defRPr>
+            </a:pPr>
+            <a:r>
+              <a:t>$750K Grant Sitting Idle</a:t>
+            </a:r>
+          </a:p>
+          <a:p>
+            <a:pPr>
+              <a:spcBef>
+                <a:spcPts val="400"/>
+              </a:spcBef>
+              <a:defRPr sz="1000">
+                <a:solidFill>
+                  <a:srgbClr val="475569"/>
+                </a:solidFill>
+              </a:defRPr>
+            </a:pPr>
+            <a:r>
+              <a:t>- Federal IRA Direct Pay pays 30% to 50% in cash</a:t>
+            </a:r>
+          </a:p>
+          <a:p>
+            <a:pPr>
+              <a:spcBef>
+                <a:spcPts val="400"/>
+              </a:spcBef>
+              <a:defRPr sz="1000">
+                <a:solidFill>
+                  <a:srgbClr val="475569"/>
+                </a:solidFill>
+              </a:defRPr>
+            </a:pPr>
+            <a:r>
+              <a:t>- Over 90% of school boards don't know it exists!</a:t>
+            </a:r>
+          </a:p>
+          <a:p>
+            <a:pPr>
+              <a:spcBef>
+                <a:spcPts val="400"/>
+              </a:spcBef>
+              <a:defRPr sz="1000">
+                <a:solidFill>
+                  <a:srgbClr val="475569"/>
+                </a:solidFill>
+              </a:defRPr>
+            </a:pPr>
+            <a:r>
+              <a:t>- Private consultant studies cost $25K and take a year</a:t>
             </a:r>
           </a:p>
         </p:txBody>
@@ -5095,7 +5082,7 @@
             <a:avLst/>
           </a:prstGeom>
           <a:solidFill>
-            <a:srgbClr val="0B0F19"/>
+            <a:srgbClr val="F8FAFC"/>
           </a:solidFill>
           <a:ln>
             <a:noFill/>
@@ -5138,10 +5125,12 @@
             <a:avLst/>
           </a:prstGeom>
           <a:solidFill>
-            <a:srgbClr val="0F172A"/>
+            <a:srgbClr val="F1F5F9"/>
           </a:solidFill>
-          <a:ln>
-            <a:noFill/>
+          <a:ln w="12700">
+            <a:solidFill>
+              <a:srgbClr val="E2E8F0"/>
+            </a:solidFill>
           </a:ln>
         </p:spPr>
         <p:style>
@@ -5243,7 +5232,7 @@
             <a:pPr>
               <a:defRPr sz="950">
                 <a:solidFill>
-                  <a:srgbClr val="A0AEC0"/>
+                  <a:srgbClr val="475569"/>
                 </a:solidFill>
               </a:defRPr>
             </a:pPr>
@@ -5278,7 +5267,7 @@
             <a:pPr algn="r">
               <a:defRPr sz="1000" b="1">
                 <a:solidFill>
-                  <a:srgbClr val="38BDF8"/>
+                  <a:srgbClr val="0284C7"/>
                 </a:solidFill>
               </a:defRPr>
             </a:pPr>
@@ -5303,7 +5292,7 @@
             <a:avLst/>
           </a:prstGeom>
           <a:solidFill>
-            <a:srgbClr val="38BDF8"/>
+            <a:srgbClr val="0284C7"/>
           </a:solidFill>
           <a:ln>
             <a:noFill/>
@@ -5356,7 +5345,7 @@
             <a:pPr>
               <a:defRPr sz="900" b="1">
                 <a:solidFill>
-                  <a:srgbClr val="38BDF8"/>
+                  <a:srgbClr val="0284C7"/>
                 </a:solidFill>
               </a:defRPr>
             </a:pPr>
@@ -5371,7 +5360,7 @@
               </a:spcBef>
               <a:defRPr sz="2200" b="1">
                 <a:solidFill>
-                  <a:srgbClr val="F8FAFC"/>
+                  <a:srgbClr val="0F172A"/>
                 </a:solidFill>
               </a:defRPr>
             </a:pPr>
@@ -5386,7 +5375,7 @@
               </a:spcBef>
               <a:defRPr sz="1100">
                 <a:solidFill>
-                  <a:srgbClr val="A0AEC0"/>
+                  <a:srgbClr val="475569"/>
                 </a:solidFill>
               </a:defRPr>
             </a:pPr>
@@ -5411,11 +5400,11 @@
             <a:avLst/>
           </a:prstGeom>
           <a:solidFill>
-            <a:srgbClr val="131A2B"/>
+            <a:srgbClr val="FFFFFF"/>
           </a:solidFill>
           <a:ln w="12700">
             <a:solidFill>
-              <a:srgbClr val="222E4A"/>
+              <a:srgbClr val="E2E8F0"/>
             </a:solidFill>
           </a:ln>
         </p:spPr>
@@ -5456,7 +5445,7 @@
             <a:avLst/>
           </a:prstGeom>
           <a:solidFill>
-            <a:srgbClr val="38BDF8"/>
+            <a:srgbClr val="0284C7"/>
           </a:solidFill>
           <a:ln>
             <a:noFill/>
@@ -5507,9 +5496,9 @@
           <a:lstStyle/>
           <a:p>
             <a:pPr>
-              <a:defRPr sz="2600" b="1">
-                <a:solidFill>
-                  <a:srgbClr val="38BDF8"/>
+              <a:defRPr sz="2400" b="1">
+                <a:solidFill>
+                  <a:srgbClr val="0284C7"/>
                 </a:solidFill>
               </a:defRPr>
             </a:pPr>
@@ -5524,7 +5513,7 @@
               </a:spcBef>
               <a:defRPr sz="900" b="1">
                 <a:solidFill>
-                  <a:srgbClr val="F8FAFC"/>
+                  <a:srgbClr val="0F172A"/>
                 </a:solidFill>
               </a:defRPr>
             </a:pPr>
@@ -5539,7 +5528,7 @@
               </a:spcBef>
               <a:defRPr sz="1000">
                 <a:solidFill>
-                  <a:srgbClr val="A0AEC0"/>
+                  <a:srgbClr val="475569"/>
                 </a:solidFill>
               </a:defRPr>
             </a:pPr>
@@ -5554,7 +5543,7 @@
               </a:spcBef>
               <a:defRPr sz="1000">
                 <a:solidFill>
-                  <a:srgbClr val="A0AEC0"/>
+                  <a:srgbClr val="475569"/>
                 </a:solidFill>
               </a:defRPr>
             </a:pPr>
@@ -5569,12 +5558,27 @@
               </a:spcBef>
               <a:defRPr sz="1000">
                 <a:solidFill>
-                  <a:srgbClr val="A0AEC0"/>
-                </a:solidFill>
-              </a:defRPr>
-            </a:pPr>
-            <a:r>
-              <a:t>- See your school's exact energy and savings in 5 seconds</a:t>
+                  <a:srgbClr val="475569"/>
+                </a:solidFill>
+              </a:defRPr>
+            </a:pPr>
+            <a:r>
+              <a:t>- See your school's exact savings in 5 seconds</a:t>
+            </a:r>
+          </a:p>
+          <a:p>
+            <a:pPr>
+              <a:spcBef>
+                <a:spcPts val="600"/>
+              </a:spcBef>
+              <a:defRPr sz="1000">
+                <a:solidFill>
+                  <a:srgbClr val="475569"/>
+                </a:solidFill>
+              </a:defRPr>
+            </a:pPr>
+            <a:r>
+              <a:t>- Completely free for students, parents &amp; staff</a:t>
             </a:r>
           </a:p>
         </p:txBody>
@@ -5594,11 +5598,11 @@
             <a:avLst/>
           </a:prstGeom>
           <a:solidFill>
-            <a:srgbClr val="131A2B"/>
+            <a:srgbClr val="FFFFFF"/>
           </a:solidFill>
           <a:ln w="12700">
             <a:solidFill>
-              <a:srgbClr val="222E4A"/>
+              <a:srgbClr val="E2E8F0"/>
             </a:solidFill>
           </a:ln>
         </p:spPr>
@@ -5639,7 +5643,7 @@
             <a:avLst/>
           </a:prstGeom>
           <a:solidFill>
-            <a:srgbClr val="10B981"/>
+            <a:srgbClr val="059669"/>
           </a:solidFill>
           <a:ln>
             <a:noFill/>
@@ -5690,9 +5694,9 @@
           <a:lstStyle/>
           <a:p>
             <a:pPr>
-              <a:defRPr sz="2600" b="1">
-                <a:solidFill>
-                  <a:srgbClr val="10B981"/>
+              <a:defRPr sz="2400" b="1">
+                <a:solidFill>
+                  <a:srgbClr val="059669"/>
                 </a:solidFill>
               </a:defRPr>
             </a:pPr>
@@ -5707,7 +5711,7 @@
               </a:spcBef>
               <a:defRPr sz="900" b="1">
                 <a:solidFill>
-                  <a:srgbClr val="F8FAFC"/>
+                  <a:srgbClr val="0F172A"/>
                 </a:solidFill>
               </a:defRPr>
             </a:pPr>
@@ -5722,7 +5726,7 @@
               </a:spcBef>
               <a:defRPr sz="1000">
                 <a:solidFill>
-                  <a:srgbClr val="A0AEC0"/>
+                  <a:srgbClr val="475569"/>
                 </a:solidFill>
               </a:defRPr>
             </a:pPr>
@@ -5737,7 +5741,7 @@
               </a:spcBef>
               <a:defRPr sz="1000">
                 <a:solidFill>
-                  <a:srgbClr val="A0AEC0"/>
+                  <a:srgbClr val="475569"/>
                 </a:solidFill>
               </a:defRPr>
             </a:pPr>
@@ -5752,12 +5756,27 @@
               </a:spcBef>
               <a:defRPr sz="1000">
                 <a:solidFill>
-                  <a:srgbClr val="A0AEC0"/>
-                </a:solidFill>
-              </a:defRPr>
-            </a:pPr>
-            <a:r>
-              <a:t>- Share it with your principal, teachers, and student council</a:t>
+                  <a:srgbClr val="475569"/>
+                </a:solidFill>
+              </a:defRPr>
+            </a:pPr>
+            <a:r>
+              <a:t>- Share it with your principal, teachers, and council</a:t>
+            </a:r>
+          </a:p>
+          <a:p>
+            <a:pPr>
+              <a:spcBef>
+                <a:spcPts val="600"/>
+              </a:spcBef>
+              <a:defRPr sz="1000">
+                <a:solidFill>
+                  <a:srgbClr val="475569"/>
+                </a:solidFill>
+              </a:defRPr>
+            </a:pPr>
+            <a:r>
+              <a:t>- Backed by real Department of Energy calculations</a:t>
             </a:r>
           </a:p>
         </p:txBody>
@@ -5777,11 +5796,11 @@
             <a:avLst/>
           </a:prstGeom>
           <a:solidFill>
-            <a:srgbClr val="131A2B"/>
+            <a:srgbClr val="FFFFFF"/>
           </a:solidFill>
           <a:ln w="12700">
             <a:solidFill>
-              <a:srgbClr val="222E4A"/>
+              <a:srgbClr val="E2E8F0"/>
             </a:solidFill>
           </a:ln>
         </p:spPr>
@@ -5873,7 +5892,7 @@
           <a:lstStyle/>
           <a:p>
             <a:pPr>
-              <a:defRPr sz="2600" b="1">
+              <a:defRPr sz="2400" b="1">
                 <a:solidFill>
                   <a:srgbClr val="8C1515"/>
                 </a:solidFill>
@@ -5890,7 +5909,7 @@
               </a:spcBef>
               <a:defRPr sz="900" b="1">
                 <a:solidFill>
-                  <a:srgbClr val="F8FAFC"/>
+                  <a:srgbClr val="0F172A"/>
                 </a:solidFill>
               </a:defRPr>
             </a:pPr>
@@ -5905,7 +5924,7 @@
               </a:spcBef>
               <a:defRPr sz="1000">
                 <a:solidFill>
-                  <a:srgbClr val="A0AEC0"/>
+                  <a:srgbClr val="475569"/>
                 </a:solidFill>
               </a:defRPr>
             </a:pPr>
@@ -5920,12 +5939,12 @@
               </a:spcBef>
               <a:defRPr sz="1000">
                 <a:solidFill>
-                  <a:srgbClr val="A0AEC0"/>
-                </a:solidFill>
-              </a:defRPr>
-            </a:pPr>
-            <a:r>
-              <a:t>- Show trustees how to claim federal cash before it expires</a:t>
+                  <a:srgbClr val="475569"/>
+                </a:solidFill>
+              </a:defRPr>
+            </a:pPr>
+            <a:r>
+              <a:t>- Show trustees how to claim federal cash now</a:t>
             </a:r>
           </a:p>
           <a:p>
@@ -5935,12 +5954,27 @@
               </a:spcBef>
               <a:defRPr sz="1000">
                 <a:solidFill>
-                  <a:srgbClr val="A0AEC0"/>
-                </a:solidFill>
-              </a:defRPr>
-            </a:pPr>
-            <a:r>
-              <a:t>- Turn student climate advocacy into real, funded infrastructure</a:t>
+                  <a:srgbClr val="475569"/>
+                </a:solidFill>
+              </a:defRPr>
+            </a:pPr>
+            <a:r>
+              <a:t>- Turn student climate advocacy into real infrastructure</a:t>
+            </a:r>
+          </a:p>
+          <a:p>
+            <a:pPr>
+              <a:spcBef>
+                <a:spcPts val="600"/>
+              </a:spcBef>
+              <a:defRPr sz="1000">
+                <a:solidFill>
+                  <a:srgbClr val="475569"/>
+                </a:solidFill>
+              </a:defRPr>
+            </a:pPr>
+            <a:r>
+              <a:t>- Leave the microphone with a concrete proposal</a:t>
             </a:r>
           </a:p>
         </p:txBody>
@@ -5960,7 +5994,7 @@
             <a:avLst/>
           </a:prstGeom>
           <a:solidFill>
-            <a:srgbClr val="131A2B"/>
+            <a:srgbClr val="FFFFFF"/>
           </a:solidFill>
           <a:ln w="12700">
             <a:solidFill>
@@ -6015,7 +6049,7 @@
             <a:pPr>
               <a:defRPr sz="900" b="1">
                 <a:solidFill>
-                  <a:srgbClr val="38BDF8"/>
+                  <a:srgbClr val="8C1515"/>
                 </a:solidFill>
               </a:defRPr>
             </a:pPr>
@@ -6030,7 +6064,7 @@
               </a:spcBef>
               <a:defRPr sz="1100" b="1">
                 <a:solidFill>
-                  <a:srgbClr val="F8FAFC"/>
+                  <a:srgbClr val="0F172A"/>
                 </a:solidFill>
               </a:defRPr>
             </a:pPr>
@@ -6073,7 +6107,7 @@
             <a:avLst/>
           </a:prstGeom>
           <a:solidFill>
-            <a:srgbClr val="0B0F19"/>
+            <a:srgbClr val="F8FAFC"/>
           </a:solidFill>
           <a:ln>
             <a:noFill/>
@@ -6116,10 +6150,12 @@
             <a:avLst/>
           </a:prstGeom>
           <a:solidFill>
-            <a:srgbClr val="0F172A"/>
+            <a:srgbClr val="F1F5F9"/>
           </a:solidFill>
-          <a:ln>
-            <a:noFill/>
+          <a:ln w="12700">
+            <a:solidFill>
+              <a:srgbClr val="E2E8F0"/>
+            </a:solidFill>
           </a:ln>
         </p:spPr>
         <p:style>
@@ -6221,7 +6257,7 @@
             <a:pPr>
               <a:defRPr sz="950">
                 <a:solidFill>
-                  <a:srgbClr val="A0AEC0"/>
+                  <a:srgbClr val="475569"/>
                 </a:solidFill>
               </a:defRPr>
             </a:pPr>
@@ -6256,7 +6292,7 @@
             <a:pPr algn="r">
               <a:defRPr sz="1000" b="1">
                 <a:solidFill>
-                  <a:srgbClr val="38BDF8"/>
+                  <a:srgbClr val="0284C7"/>
                 </a:solidFill>
               </a:defRPr>
             </a:pPr>
@@ -6281,7 +6317,7 @@
             <a:avLst/>
           </a:prstGeom>
           <a:solidFill>
-            <a:srgbClr val="38BDF8"/>
+            <a:srgbClr val="0284C7"/>
           </a:solidFill>
           <a:ln>
             <a:noFill/>
@@ -6334,12 +6370,12 @@
             <a:pPr>
               <a:defRPr sz="900" b="1">
                 <a:solidFill>
-                  <a:srgbClr val="38BDF8"/>
-                </a:solidFill>
-              </a:defRPr>
-            </a:pPr>
-            <a:r>
-              <a:t>THE REAL PROBLEM</a:t>
+                  <a:srgbClr val="0284C7"/>
+                </a:solidFill>
+              </a:defRPr>
+            </a:pPr>
+            <a:r>
+              <a:t>THE ROADBLOCKS</a:t>
             </a:r>
           </a:p>
           <a:p>
@@ -6349,12 +6385,12 @@
               </a:spcBef>
               <a:defRPr sz="2200" b="1">
                 <a:solidFill>
-                  <a:srgbClr val="F8FAFC"/>
-                </a:solidFill>
-              </a:defRPr>
-            </a:pPr>
-            <a:r>
-              <a:t>Our Parking Lots Are Baking. Our Schools Are Bleeding Cash.</a:t>
+                  <a:srgbClr val="0F172A"/>
+                </a:solidFill>
+              </a:defRPr>
+            </a:pPr>
+            <a:r>
+              <a:t>Why Haven't Schools Solved This Already?</a:t>
             </a:r>
           </a:p>
           <a:p>
@@ -6364,12 +6400,12 @@
               </a:spcBef>
               <a:defRPr sz="1100">
                 <a:solidFill>
-                  <a:srgbClr val="A0AEC0"/>
-                </a:solidFill>
-              </a:defRPr>
-            </a:pPr>
-            <a:r>
-              <a:t>Millions of square feet of black asphalt are absorbing heat and draining school budgets.</a:t>
+                  <a:srgbClr val="475569"/>
+                </a:solidFill>
+              </a:defRPr>
+            </a:pPr>
+            <a:r>
+              <a:t>Two major institutional barriers have kept clean energy out of public school parking lots.</a:t>
             </a:r>
           </a:p>
         </p:txBody>
@@ -6389,11 +6425,11 @@
             <a:avLst/>
           </a:prstGeom>
           <a:solidFill>
-            <a:srgbClr val="131A2B"/>
+            <a:srgbClr val="FFFFFF"/>
           </a:solidFill>
           <a:ln w="12700">
             <a:solidFill>
-              <a:srgbClr val="222E4A"/>
+              <a:srgbClr val="E2E8F0"/>
             </a:solidFill>
           </a:ln>
         </p:spPr>
@@ -6434,7 +6470,7 @@
             <a:avLst/>
           </a:prstGeom>
           <a:solidFill>
-            <a:srgbClr val="EF4444"/>
+            <a:srgbClr val="DC2626"/>
           </a:solidFill>
           <a:ln>
             <a:noFill/>
@@ -6485,14 +6521,14 @@
           <a:lstStyle/>
           <a:p>
             <a:pPr>
-              <a:defRPr sz="3800" b="1">
-                <a:solidFill>
-                  <a:srgbClr val="EF4444"/>
-                </a:solidFill>
-              </a:defRPr>
-            </a:pPr>
-            <a:r>
-              <a:t>140°F</a:t>
+              <a:defRPr sz="2200" b="1">
+                <a:solidFill>
+                  <a:srgbClr val="DC2626"/>
+                </a:solidFill>
+              </a:defRPr>
+            </a:pPr>
+            <a:r>
+              <a:t>Barrier 1</a:t>
             </a:r>
           </a:p>
           <a:p>
@@ -6500,14 +6536,14 @@
               <a:spcBef>
                 <a:spcPts val="200"/>
               </a:spcBef>
-              <a:defRPr sz="900" b="1">
-                <a:solidFill>
-                  <a:srgbClr val="F8FAFC"/>
-                </a:solidFill>
-              </a:defRPr>
-            </a:pPr>
-            <a:r>
-              <a:t>BLAZING ASPHALT</a:t>
+              <a:defRPr sz="1100" b="1">
+                <a:solidFill>
+                  <a:srgbClr val="0F172A"/>
+                </a:solidFill>
+              </a:defRPr>
+            </a:pPr>
+            <a:r>
+              <a:t>TAX-EXEMPT LOCKOUT</a:t>
             </a:r>
           </a:p>
           <a:p>
@@ -6517,12 +6553,12 @@
               </a:spcBef>
               <a:defRPr sz="1000">
                 <a:solidFill>
-                  <a:srgbClr val="A0AEC0"/>
-                </a:solidFill>
-              </a:defRPr>
-            </a:pPr>
-            <a:r>
-              <a:t>- Empty blacktop bakes student and staff cars</a:t>
+                  <a:srgbClr val="475569"/>
+                </a:solidFill>
+              </a:defRPr>
+            </a:pPr>
+            <a:r>
+              <a:t>- Schools don't pay federal income taxes</a:t>
             </a:r>
           </a:p>
           <a:p>
@@ -6532,12 +6568,12 @@
               </a:spcBef>
               <a:defRPr sz="1000">
                 <a:solidFill>
-                  <a:srgbClr val="A0AEC0"/>
-                </a:solidFill>
-              </a:defRPr>
-            </a:pPr>
-            <a:r>
-              <a:t>- Creates campus heat islands in hot months</a:t>
+                  <a:srgbClr val="475569"/>
+                </a:solidFill>
+              </a:defRPr>
+            </a:pPr>
+            <a:r>
+              <a:t>- Historically locked out of traditional solar tax credits</a:t>
             </a:r>
           </a:p>
           <a:p>
@@ -6547,12 +6583,27 @@
               </a:spcBef>
               <a:defRPr sz="1000">
                 <a:solidFill>
-                  <a:srgbClr val="A0AEC0"/>
-                </a:solidFill>
-              </a:defRPr>
-            </a:pPr>
-            <a:r>
-              <a:t>- Playground asphalt gets too hot to use safely</a:t>
+                  <a:srgbClr val="475569"/>
+                </a:solidFill>
+              </a:defRPr>
+            </a:pPr>
+            <a:r>
+              <a:t>- Forced into predatory third-party lease deals</a:t>
+            </a:r>
+          </a:p>
+          <a:p>
+            <a:pPr>
+              <a:spcBef>
+                <a:spcPts val="600"/>
+              </a:spcBef>
+              <a:defRPr sz="1000">
+                <a:solidFill>
+                  <a:srgbClr val="475569"/>
+                </a:solidFill>
+              </a:defRPr>
+            </a:pPr>
+            <a:r>
+              <a:t>- Left public districts waiting on the sidelines</a:t>
             </a:r>
           </a:p>
         </p:txBody>
@@ -6572,11 +6623,11 @@
             <a:avLst/>
           </a:prstGeom>
           <a:solidFill>
-            <a:srgbClr val="131A2B"/>
+            <a:srgbClr val="FFFFFF"/>
           </a:solidFill>
           <a:ln w="12700">
             <a:solidFill>
-              <a:srgbClr val="222E4A"/>
+              <a:srgbClr val="E2E8F0"/>
             </a:solidFill>
           </a:ln>
         </p:spPr>
@@ -6617,7 +6668,7 @@
             <a:avLst/>
           </a:prstGeom>
           <a:solidFill>
-            <a:srgbClr val="EF4444"/>
+            <a:srgbClr val="DC2626"/>
           </a:solidFill>
           <a:ln>
             <a:noFill/>
@@ -6668,14 +6719,14 @@
           <a:lstStyle/>
           <a:p>
             <a:pPr>
-              <a:defRPr sz="3800" b="1">
-                <a:solidFill>
-                  <a:srgbClr val="EF4444"/>
-                </a:solidFill>
-              </a:defRPr>
-            </a:pPr>
-            <a:r>
-              <a:t>$8.0 Billion</a:t>
+              <a:defRPr sz="2200" b="1">
+                <a:solidFill>
+                  <a:srgbClr val="DC2626"/>
+                </a:solidFill>
+              </a:defRPr>
+            </a:pPr>
+            <a:r>
+              <a:t>Barrier 2</a:t>
             </a:r>
           </a:p>
           <a:p>
@@ -6683,14 +6734,14 @@
               <a:spcBef>
                 <a:spcPts val="200"/>
               </a:spcBef>
-              <a:defRPr sz="900" b="1">
-                <a:solidFill>
-                  <a:srgbClr val="F8FAFC"/>
-                </a:solidFill>
-              </a:defRPr>
-            </a:pPr>
-            <a:r>
-              <a:t>WASTED POWER BILLS</a:t>
+              <a:defRPr sz="1100" b="1">
+                <a:solidFill>
+                  <a:srgbClr val="0F172A"/>
+                </a:solidFill>
+              </a:defRPr>
+            </a:pPr>
+            <a:r>
+              <a:t>THE $25,000 CONSULTANT WALL</a:t>
             </a:r>
           </a:p>
           <a:p>
@@ -6700,12 +6751,12 @@
               </a:spcBef>
               <a:defRPr sz="1000">
                 <a:solidFill>
-                  <a:srgbClr val="A0AEC0"/>
-                </a:solidFill>
-              </a:defRPr>
-            </a:pPr>
-            <a:r>
-              <a:t>- Schools spend more on electricity than supplies</a:t>
+                  <a:srgbClr val="475569"/>
+                </a:solidFill>
+              </a:defRPr>
+            </a:pPr>
+            <a:r>
+              <a:t>- Private solar studies cost $15,000 to $25,000 per school</a:t>
             </a:r>
           </a:p>
           <a:p>
@@ -6715,12 +6766,12 @@
               </a:spcBef>
               <a:defRPr sz="1000">
                 <a:solidFill>
-                  <a:srgbClr val="A0AEC0"/>
-                </a:solidFill>
-              </a:defRPr>
-            </a:pPr>
-            <a:r>
-              <a:t>- Money flows straight to monopoly power companies</a:t>
+                  <a:srgbClr val="475569"/>
+                </a:solidFill>
+              </a:defRPr>
+            </a:pPr>
+            <a:r>
+              <a:t>- Takes 6 to 12 months just to get an estimate</a:t>
             </a:r>
           </a:p>
           <a:p>
@@ -6730,12 +6781,27 @@
               </a:spcBef>
               <a:defRPr sz="1000">
                 <a:solidFill>
-                  <a:srgbClr val="A0AEC0"/>
-                </a:solidFill>
-              </a:defRPr>
-            </a:pPr>
-            <a:r>
-              <a:t>- Funds that could hire teachers are lost every year</a:t>
+                  <a:srgbClr val="475569"/>
+                </a:solidFill>
+              </a:defRPr>
+            </a:pPr>
+            <a:r>
+              <a:t>- Under-funded schools cannot afford upfront studies</a:t>
+            </a:r>
+          </a:p>
+          <a:p>
+            <a:pPr>
+              <a:spcBef>
+                <a:spcPts val="600"/>
+              </a:spcBef>
+              <a:defRPr sz="1000">
+                <a:solidFill>
+                  <a:srgbClr val="475569"/>
+                </a:solidFill>
+              </a:defRPr>
+            </a:pPr>
+            <a:r>
+              <a:t>- Stalls school board action indefinitely</a:t>
             </a:r>
           </a:p>
         </p:txBody>
@@ -6755,11 +6821,11 @@
             <a:avLst/>
           </a:prstGeom>
           <a:solidFill>
-            <a:srgbClr val="131A2B"/>
+            <a:srgbClr val="FFFFFF"/>
           </a:solidFill>
           <a:ln w="12700">
             <a:solidFill>
-              <a:srgbClr val="222E4A"/>
+              <a:srgbClr val="E2E8F0"/>
             </a:solidFill>
           </a:ln>
         </p:spPr>
@@ -6800,7 +6866,7 @@
             <a:avLst/>
           </a:prstGeom>
           <a:solidFill>
-            <a:srgbClr val="EF4444"/>
+            <a:srgbClr val="D97706"/>
           </a:solidFill>
           <a:ln>
             <a:noFill/>
@@ -6851,14 +6917,14 @@
           <a:lstStyle/>
           <a:p>
             <a:pPr>
-              <a:defRPr sz="3800" b="1">
-                <a:solidFill>
-                  <a:srgbClr val="EF4444"/>
-                </a:solidFill>
-              </a:defRPr>
-            </a:pPr>
-            <a:r>
-              <a:t>$25,000</a:t>
+              <a:defRPr sz="2200" b="1">
+                <a:solidFill>
+                  <a:srgbClr val="D97706"/>
+                </a:solidFill>
+              </a:defRPr>
+            </a:pPr>
+            <a:r>
+              <a:t>The Cost</a:t>
             </a:r>
           </a:p>
           <a:p>
@@ -6866,14 +6932,14 @@
               <a:spcBef>
                 <a:spcPts val="200"/>
               </a:spcBef>
-              <a:defRPr sz="900" b="1">
-                <a:solidFill>
-                  <a:srgbClr val="F8FAFC"/>
-                </a:solidFill>
-              </a:defRPr>
-            </a:pPr>
-            <a:r>
-              <a:t>THE CONSULTANT WALL</a:t>
+              <a:defRPr sz="1100" b="1">
+                <a:solidFill>
+                  <a:srgbClr val="0F172A"/>
+                </a:solidFill>
+              </a:defRPr>
+            </a:pPr>
+            <a:r>
+              <a:t>$140,000 LOST EVERY YEAR</a:t>
             </a:r>
           </a:p>
           <a:p>
@@ -6883,12 +6949,12 @@
               </a:spcBef>
               <a:defRPr sz="1000">
                 <a:solidFill>
-                  <a:srgbClr val="A0AEC0"/>
-                </a:solidFill>
-              </a:defRPr>
-            </a:pPr>
-            <a:r>
-              <a:t>- Engineering feasibility studies cost thousands</a:t>
+                  <a:srgbClr val="475569"/>
+                </a:solidFill>
+              </a:defRPr>
+            </a:pPr>
+            <a:r>
+              <a:t>- Every single year a high school waits is $140K lost</a:t>
             </a:r>
           </a:p>
           <a:p>
@@ -6898,12 +6964,12 @@
               </a:spcBef>
               <a:defRPr sz="1000">
                 <a:solidFill>
-                  <a:srgbClr val="A0AEC0"/>
-                </a:solidFill>
-              </a:defRPr>
-            </a:pPr>
-            <a:r>
-              <a:t>- Takes 6 to 12 months just to get an estimate</a:t>
+                  <a:srgbClr val="475569"/>
+                </a:solidFill>
+              </a:defRPr>
+            </a:pPr>
+            <a:r>
+              <a:t>- That is enough to fund 2 full-time teacher salaries!</a:t>
             </a:r>
           </a:p>
           <a:p>
@@ -6913,12 +6979,27 @@
               </a:spcBef>
               <a:defRPr sz="1000">
                 <a:solidFill>
-                  <a:srgbClr val="A0AEC0"/>
-                </a:solidFill>
-              </a:defRPr>
-            </a:pPr>
-            <a:r>
-              <a:t>- Leaves under-resourced schools completely locked out</a:t>
+                  <a:srgbClr val="475569"/>
+                </a:solidFill>
+              </a:defRPr>
+            </a:pPr>
+            <a:r>
+              <a:t>- Over 5 years, delay costs a school over $700,000</a:t>
+            </a:r>
+          </a:p>
+          <a:p>
+            <a:pPr>
+              <a:spcBef>
+                <a:spcPts val="600"/>
+              </a:spcBef>
+              <a:defRPr sz="1000">
+                <a:solidFill>
+                  <a:srgbClr val="475569"/>
+                </a:solidFill>
+              </a:defRPr>
+            </a:pPr>
+            <a:r>
+              <a:t>- Students lose out on classroom resources</a:t>
             </a:r>
           </a:p>
         </p:txBody>
@@ -6938,11 +7019,11 @@
             <a:avLst/>
           </a:prstGeom>
           <a:solidFill>
-            <a:srgbClr val="131A2B"/>
+            <a:srgbClr val="FFFFFF"/>
           </a:solidFill>
           <a:ln w="12700">
             <a:solidFill>
-              <a:srgbClr val="EF4444"/>
+              <a:srgbClr val="DC2626"/>
             </a:solidFill>
           </a:ln>
         </p:spPr>
@@ -6993,7 +7074,7 @@
             <a:pPr>
               <a:defRPr sz="900" b="1">
                 <a:solidFill>
-                  <a:srgbClr val="EF4444"/>
+                  <a:srgbClr val="DC2626"/>
                 </a:solidFill>
               </a:defRPr>
             </a:pPr>
@@ -7006,14 +7087,14 @@
               <a:spcBef>
                 <a:spcPts val="200"/>
               </a:spcBef>
-              <a:defRPr sz="1100" b="1">
-                <a:solidFill>
-                  <a:srgbClr val="F8FAFC"/>
-                </a:solidFill>
-              </a:defRPr>
-            </a:pPr>
-            <a:r>
-              <a:t>Every dollar our school district pays to utility companies is a dollar taken away from teachers, arts, and classrooms.</a:t>
+              <a:defRPr sz="1050" b="1">
+                <a:solidFill>
+                  <a:srgbClr val="0F172A"/>
+                </a:solidFill>
+              </a:defRPr>
+            </a:pPr>
+            <a:r>
+              <a:t>School boards want to go green, but expensive consultants and confusing tax laws hold them back. We need a free tool that gives them answers instantly.</a:t>
             </a:r>
           </a:p>
         </p:txBody>
@@ -7051,7 +7132,7 @@
             <a:avLst/>
           </a:prstGeom>
           <a:solidFill>
-            <a:srgbClr val="0B0F19"/>
+            <a:srgbClr val="F8FAFC"/>
           </a:solidFill>
           <a:ln>
             <a:noFill/>
@@ -7094,10 +7175,12 @@
             <a:avLst/>
           </a:prstGeom>
           <a:solidFill>
-            <a:srgbClr val="0F172A"/>
+            <a:srgbClr val="F1F5F9"/>
           </a:solidFill>
-          <a:ln>
-            <a:noFill/>
+          <a:ln w="12700">
+            <a:solidFill>
+              <a:srgbClr val="E2E8F0"/>
+            </a:solidFill>
           </a:ln>
         </p:spPr>
         <p:style>
@@ -7199,7 +7282,7 @@
             <a:pPr>
               <a:defRPr sz="950">
                 <a:solidFill>
-                  <a:srgbClr val="A0AEC0"/>
+                  <a:srgbClr val="475569"/>
                 </a:solidFill>
               </a:defRPr>
             </a:pPr>
@@ -7234,7 +7317,7 @@
             <a:pPr algn="r">
               <a:defRPr sz="1000" b="1">
                 <a:solidFill>
-                  <a:srgbClr val="38BDF8"/>
+                  <a:srgbClr val="0284C7"/>
                 </a:solidFill>
               </a:defRPr>
             </a:pPr>
@@ -7259,7 +7342,7 @@
             <a:avLst/>
           </a:prstGeom>
           <a:solidFill>
-            <a:srgbClr val="38BDF8"/>
+            <a:srgbClr val="0284C7"/>
           </a:solidFill>
           <a:ln>
             <a:noFill/>
@@ -7312,7 +7395,7 @@
             <a:pPr>
               <a:defRPr sz="900" b="1">
                 <a:solidFill>
-                  <a:srgbClr val="38BDF8"/>
+                  <a:srgbClr val="0284C7"/>
                 </a:solidFill>
               </a:defRPr>
             </a:pPr>
@@ -7327,7 +7410,7 @@
               </a:spcBef>
               <a:defRPr sz="2200" b="1">
                 <a:solidFill>
-                  <a:srgbClr val="F8FAFC"/>
+                  <a:srgbClr val="0F172A"/>
                 </a:solidFill>
               </a:defRPr>
             </a:pPr>
@@ -7342,7 +7425,7 @@
               </a:spcBef>
               <a:defRPr sz="1100">
                 <a:solidFill>
-                  <a:srgbClr val="A0AEC0"/>
+                  <a:srgbClr val="475569"/>
                 </a:solidFill>
               </a:defRPr>
             </a:pPr>
@@ -7367,11 +7450,11 @@
             <a:avLst/>
           </a:prstGeom>
           <a:solidFill>
-            <a:srgbClr val="131A2B"/>
+            <a:srgbClr val="FFFFFF"/>
           </a:solidFill>
           <a:ln w="12700">
             <a:solidFill>
-              <a:srgbClr val="222E4A"/>
+              <a:srgbClr val="E2E8F0"/>
             </a:solidFill>
           </a:ln>
         </p:spPr>
@@ -7412,7 +7495,7 @@
             <a:avLst/>
           </a:prstGeom>
           <a:solidFill>
-            <a:srgbClr val="10B981"/>
+            <a:srgbClr val="059669"/>
           </a:solidFill>
           <a:ln>
             <a:noFill/>
@@ -7463,9 +7546,9 @@
           <a:lstStyle/>
           <a:p>
             <a:pPr>
-              <a:defRPr sz="3800" b="1">
-                <a:solidFill>
-                  <a:srgbClr val="10B981"/>
+              <a:defRPr sz="3600" b="1">
+                <a:solidFill>
+                  <a:srgbClr val="059669"/>
                 </a:solidFill>
               </a:defRPr>
             </a:pPr>
@@ -7480,7 +7563,7 @@
               </a:spcBef>
               <a:defRPr sz="900" b="1">
                 <a:solidFill>
-                  <a:srgbClr val="F8FAFC"/>
+                  <a:srgbClr val="0F172A"/>
                 </a:solidFill>
               </a:defRPr>
             </a:pPr>
@@ -7491,46 +7574,61 @@
           <a:p>
             <a:pPr>
               <a:spcBef>
-                <a:spcPts val="600"/>
+                <a:spcPts val="500"/>
               </a:spcBef>
               <a:defRPr sz="1000">
                 <a:solidFill>
-                  <a:srgbClr val="A0AEC0"/>
-                </a:solidFill>
-              </a:defRPr>
-            </a:pPr>
-            <a:r>
-              <a:t>- Federal IRS cash check covering 30% of cost</a:t>
-            </a:r>
-          </a:p>
-          <a:p>
-            <a:pPr>
-              <a:spcBef>
-                <a:spcPts val="600"/>
+                  <a:srgbClr val="475569"/>
+                </a:solidFill>
+              </a:defRPr>
+            </a:pPr>
+            <a:r>
+              <a:t>- Direct cash payment from the IRS to the district</a:t>
+            </a:r>
+          </a:p>
+          <a:p>
+            <a:pPr>
+              <a:spcBef>
+                <a:spcPts val="500"/>
               </a:spcBef>
               <a:defRPr sz="1000">
                 <a:solidFill>
-                  <a:srgbClr val="A0AEC0"/>
-                </a:solidFill>
-              </a:defRPr>
-            </a:pPr>
-            <a:r>
-              <a:t>- Direct payment to the school district treasury</a:t>
-            </a:r>
-          </a:p>
-          <a:p>
-            <a:pPr>
-              <a:spcBef>
-                <a:spcPts val="600"/>
+                  <a:srgbClr val="475569"/>
+                </a:solidFill>
+              </a:defRPr>
+            </a:pPr>
+            <a:r>
+              <a:t>- Deposited straight into the school treasury</a:t>
+            </a:r>
+          </a:p>
+          <a:p>
+            <a:pPr>
+              <a:spcBef>
+                <a:spcPts val="500"/>
               </a:spcBef>
               <a:defRPr sz="1000">
                 <a:solidFill>
-                  <a:srgbClr val="A0AEC0"/>
-                </a:solidFill>
-              </a:defRPr>
-            </a:pPr>
-            <a:r>
-              <a:t>- No tax liability needed—public schools qualify directly!</a:t>
+                  <a:srgbClr val="475569"/>
+                </a:solidFill>
+              </a:defRPr>
+            </a:pPr>
+            <a:r>
+              <a:t>- No tax liability needed: public schools qualify directly!</a:t>
+            </a:r>
+          </a:p>
+          <a:p>
+            <a:pPr>
+              <a:spcBef>
+                <a:spcPts val="500"/>
+              </a:spcBef>
+              <a:defRPr sz="1000">
+                <a:solidFill>
+                  <a:srgbClr val="475569"/>
+                </a:solidFill>
+              </a:defRPr>
+            </a:pPr>
+            <a:r>
+              <a:t>- Bypasses private tax investors and complicated leases</a:t>
             </a:r>
           </a:p>
         </p:txBody>
@@ -7550,11 +7648,11 @@
             <a:avLst/>
           </a:prstGeom>
           <a:solidFill>
-            <a:srgbClr val="131A2B"/>
+            <a:srgbClr val="FFFFFF"/>
           </a:solidFill>
           <a:ln w="12700">
             <a:solidFill>
-              <a:srgbClr val="222E4A"/>
+              <a:srgbClr val="E2E8F0"/>
             </a:solidFill>
           </a:ln>
         </p:spPr>
@@ -7595,7 +7693,7 @@
             <a:avLst/>
           </a:prstGeom>
           <a:solidFill>
-            <a:srgbClr val="38BDF8"/>
+            <a:srgbClr val="0284C7"/>
           </a:solidFill>
           <a:ln>
             <a:noFill/>
@@ -7646,9 +7744,9 @@
           <a:lstStyle/>
           <a:p>
             <a:pPr>
-              <a:defRPr sz="3800" b="1">
-                <a:solidFill>
-                  <a:srgbClr val="38BDF8"/>
+              <a:defRPr sz="3600" b="1">
+                <a:solidFill>
+                  <a:srgbClr val="0284C7"/>
                 </a:solidFill>
               </a:defRPr>
             </a:pPr>
@@ -7663,7 +7761,7 @@
               </a:spcBef>
               <a:defRPr sz="900" b="1">
                 <a:solidFill>
-                  <a:srgbClr val="F8FAFC"/>
+                  <a:srgbClr val="0F172A"/>
                 </a:solidFill>
               </a:defRPr>
             </a:pPr>
@@ -7674,26 +7772,26 @@
           <a:p>
             <a:pPr>
               <a:spcBef>
-                <a:spcPts val="600"/>
+                <a:spcPts val="500"/>
               </a:spcBef>
               <a:defRPr sz="1000">
                 <a:solidFill>
-                  <a:srgbClr val="A0AEC0"/>
-                </a:solidFill>
-              </a:defRPr>
-            </a:pPr>
-            <a:r>
-              <a:t>- +10% extra bonus for American-made steel &amp; panels</a:t>
-            </a:r>
-          </a:p>
-          <a:p>
-            <a:pPr>
-              <a:spcBef>
-                <a:spcPts val="600"/>
+                  <a:srgbClr val="475569"/>
+                </a:solidFill>
+              </a:defRPr>
+            </a:pPr>
+            <a:r>
+              <a:t>- +10% extra bonus for American-made steel and panels</a:t>
+            </a:r>
+          </a:p>
+          <a:p>
+            <a:pPr>
+              <a:spcBef>
+                <a:spcPts val="500"/>
               </a:spcBef>
               <a:defRPr sz="1000">
                 <a:solidFill>
-                  <a:srgbClr val="A0AEC0"/>
+                  <a:srgbClr val="475569"/>
                 </a:solidFill>
               </a:defRPr>
             </a:pPr>
@@ -7704,16 +7802,31 @@
           <a:p>
             <a:pPr>
               <a:spcBef>
-                <a:spcPts val="600"/>
+                <a:spcPts val="500"/>
               </a:spcBef>
               <a:defRPr sz="1000">
                 <a:solidFill>
-                  <a:srgbClr val="A0AEC0"/>
+                  <a:srgbClr val="475569"/>
                 </a:solidFill>
               </a:defRPr>
             </a:pPr>
             <a:r>
               <a:t>- Puts the biggest grants into communities that need it most</a:t>
+            </a:r>
+          </a:p>
+          <a:p>
+            <a:pPr>
+              <a:spcBef>
+                <a:spcPts val="500"/>
+              </a:spcBef>
+              <a:defRPr sz="1000">
+                <a:solidFill>
+                  <a:srgbClr val="475569"/>
+                </a:solidFill>
+              </a:defRPr>
+            </a:pPr>
+            <a:r>
+              <a:t>- Encourages local jobs and domestic manufacturing</a:t>
             </a:r>
           </a:p>
         </p:txBody>
@@ -7733,11 +7846,11 @@
             <a:avLst/>
           </a:prstGeom>
           <a:solidFill>
-            <a:srgbClr val="131A2B"/>
+            <a:srgbClr val="FFFFFF"/>
           </a:solidFill>
           <a:ln w="12700">
             <a:solidFill>
-              <a:srgbClr val="222E4A"/>
+              <a:srgbClr val="E2E8F0"/>
             </a:solidFill>
           </a:ln>
         </p:spPr>
@@ -7778,7 +7891,7 @@
             <a:avLst/>
           </a:prstGeom>
           <a:solidFill>
-            <a:srgbClr val="10B981"/>
+            <a:srgbClr val="059669"/>
           </a:solidFill>
           <a:ln>
             <a:noFill/>
@@ -7829,9 +7942,9 @@
           <a:lstStyle/>
           <a:p>
             <a:pPr>
-              <a:defRPr sz="3800" b="1">
-                <a:solidFill>
-                  <a:srgbClr val="10B981"/>
+              <a:defRPr sz="3600" b="1">
+                <a:solidFill>
+                  <a:srgbClr val="059669"/>
                 </a:solidFill>
               </a:defRPr>
             </a:pPr>
@@ -7846,7 +7959,7 @@
               </a:spcBef>
               <a:defRPr sz="900" b="1">
                 <a:solidFill>
-                  <a:srgbClr val="F8FAFC"/>
+                  <a:srgbClr val="0F172A"/>
                 </a:solidFill>
               </a:defRPr>
             </a:pPr>
@@ -7857,46 +7970,61 @@
           <a:p>
             <a:pPr>
               <a:spcBef>
-                <a:spcPts val="600"/>
+                <a:spcPts val="500"/>
               </a:spcBef>
               <a:defRPr sz="1000">
                 <a:solidFill>
-                  <a:srgbClr val="A0AEC0"/>
-                </a:solidFill>
-              </a:defRPr>
-            </a:pPr>
-            <a:r>
-              <a:t>- Up to half the solar canopy is paid by the government</a:t>
-            </a:r>
-          </a:p>
-          <a:p>
-            <a:pPr>
-              <a:spcBef>
-                <a:spcPts val="600"/>
+                  <a:srgbClr val="475569"/>
+                </a:solidFill>
+              </a:defRPr>
+            </a:pPr>
+            <a:r>
+              <a:t>- Up to half the solar canopy paid by the government</a:t>
+            </a:r>
+          </a:p>
+          <a:p>
+            <a:pPr>
+              <a:spcBef>
+                <a:spcPts val="500"/>
               </a:spcBef>
               <a:defRPr sz="1000">
                 <a:solidFill>
-                  <a:srgbClr val="A0AEC0"/>
-                </a:solidFill>
-              </a:defRPr>
-            </a:pPr>
-            <a:r>
-              <a:t>- Districts pay only the remaining net balance</a:t>
-            </a:r>
-          </a:p>
-          <a:p>
-            <a:pPr>
-              <a:spcBef>
-                <a:spcPts val="600"/>
+                  <a:srgbClr val="475569"/>
+                </a:solidFill>
+              </a:defRPr>
+            </a:pPr>
+            <a:r>
+              <a:t>- School districts pay only the remaining balance</a:t>
+            </a:r>
+          </a:p>
+          <a:p>
+            <a:pPr>
+              <a:spcBef>
+                <a:spcPts val="500"/>
               </a:spcBef>
               <a:defRPr sz="1000">
                 <a:solidFill>
-                  <a:srgbClr val="A0AEC0"/>
+                  <a:srgbClr val="475569"/>
                 </a:solidFill>
               </a:defRPr>
             </a:pPr>
             <a:r>
               <a:t>- Yet over 90% of school boards have never heard of it!</a:t>
+            </a:r>
+          </a:p>
+          <a:p>
+            <a:pPr>
+              <a:spcBef>
+                <a:spcPts val="500"/>
+              </a:spcBef>
+              <a:defRPr sz="1000">
+                <a:solidFill>
+                  <a:srgbClr val="475569"/>
+                </a:solidFill>
+              </a:defRPr>
+            </a:pPr>
+            <a:r>
+              <a:t>- Zero school bond tax hikes required</a:t>
             </a:r>
           </a:p>
         </p:txBody>
@@ -7916,11 +8044,11 @@
             <a:avLst/>
           </a:prstGeom>
           <a:solidFill>
-            <a:srgbClr val="131A2B"/>
+            <a:srgbClr val="FFFFFF"/>
           </a:solidFill>
           <a:ln w="12700">
             <a:solidFill>
-              <a:srgbClr val="10B981"/>
+              <a:srgbClr val="059669"/>
             </a:solidFill>
           </a:ln>
         </p:spPr>
@@ -7971,7 +8099,7 @@
             <a:pPr>
               <a:defRPr sz="900" b="1">
                 <a:solidFill>
-                  <a:srgbClr val="10B981"/>
+                  <a:srgbClr val="059669"/>
                 </a:solidFill>
               </a:defRPr>
             </a:pPr>
@@ -7984,9 +8112,9 @@
               <a:spcBef>
                 <a:spcPts val="200"/>
               </a:spcBef>
-              <a:defRPr sz="1050">
-                <a:solidFill>
-                  <a:srgbClr val="F8FAFC"/>
+              <a:defRPr sz="1050" b="1">
+                <a:solidFill>
+                  <a:srgbClr val="0F172A"/>
                 </a:solidFill>
               </a:defRPr>
             </a:pPr>
@@ -8029,7 +8157,7 @@
             <a:avLst/>
           </a:prstGeom>
           <a:solidFill>
-            <a:srgbClr val="0B0F19"/>
+            <a:srgbClr val="F8FAFC"/>
           </a:solidFill>
           <a:ln>
             <a:noFill/>
@@ -8072,10 +8200,12 @@
             <a:avLst/>
           </a:prstGeom>
           <a:solidFill>
-            <a:srgbClr val="0F172A"/>
+            <a:srgbClr val="F1F5F9"/>
           </a:solidFill>
-          <a:ln>
-            <a:noFill/>
+          <a:ln w="12700">
+            <a:solidFill>
+              <a:srgbClr val="E2E8F0"/>
+            </a:solidFill>
           </a:ln>
         </p:spPr>
         <p:style>
@@ -8177,7 +8307,7 @@
             <a:pPr>
               <a:defRPr sz="950">
                 <a:solidFill>
-                  <a:srgbClr val="A0AEC0"/>
+                  <a:srgbClr val="475569"/>
                 </a:solidFill>
               </a:defRPr>
             </a:pPr>
@@ -8212,7 +8342,7 @@
             <a:pPr algn="r">
               <a:defRPr sz="1000" b="1">
                 <a:solidFill>
-                  <a:srgbClr val="38BDF8"/>
+                  <a:srgbClr val="0284C7"/>
                 </a:solidFill>
               </a:defRPr>
             </a:pPr>
@@ -8237,7 +8367,7 @@
             <a:avLst/>
           </a:prstGeom>
           <a:solidFill>
-            <a:srgbClr val="38BDF8"/>
+            <a:srgbClr val="0284C7"/>
           </a:solidFill>
           <a:ln>
             <a:noFill/>
@@ -8290,7 +8420,7 @@
             <a:pPr>
               <a:defRPr sz="900" b="1">
                 <a:solidFill>
-                  <a:srgbClr val="38BDF8"/>
+                  <a:srgbClr val="0284C7"/>
                 </a:solidFill>
               </a:defRPr>
             </a:pPr>
@@ -8305,7 +8435,7 @@
               </a:spcBef>
               <a:defRPr sz="2200" b="1">
                 <a:solidFill>
-                  <a:srgbClr val="F8FAFC"/>
+                  <a:srgbClr val="0F172A"/>
                 </a:solidFill>
               </a:defRPr>
             </a:pPr>
@@ -8320,7 +8450,7 @@
               </a:spcBef>
               <a:defRPr sz="1100">
                 <a:solidFill>
-                  <a:srgbClr val="A0AEC0"/>
+                  <a:srgbClr val="475569"/>
                 </a:solidFill>
               </a:defRPr>
             </a:pPr>
@@ -8345,11 +8475,11 @@
             <a:avLst/>
           </a:prstGeom>
           <a:solidFill>
-            <a:srgbClr val="131A2B"/>
+            <a:srgbClr val="FFFFFF"/>
           </a:solidFill>
           <a:ln w="12700">
             <a:solidFill>
-              <a:srgbClr val="222E4A"/>
+              <a:srgbClr val="E2E8F0"/>
             </a:solidFill>
           </a:ln>
         </p:spPr>
@@ -8390,7 +8520,7 @@
             <a:avLst/>
           </a:prstGeom>
           <a:solidFill>
-            <a:srgbClr val="38BDF8"/>
+            <a:srgbClr val="0284C7"/>
           </a:solidFill>
           <a:ln>
             <a:noFill/>
@@ -8441,9 +8571,9 @@
           <a:lstStyle/>
           <a:p>
             <a:pPr>
-              <a:defRPr sz="2400" b="1">
-                <a:solidFill>
-                  <a:srgbClr val="38BDF8"/>
+              <a:defRPr sz="2200" b="1">
+                <a:solidFill>
+                  <a:srgbClr val="0284C7"/>
                 </a:solidFill>
               </a:defRPr>
             </a:pPr>
@@ -8458,7 +8588,7 @@
               </a:spcBef>
               <a:defRPr sz="1100" b="1">
                 <a:solidFill>
-                  <a:srgbClr val="F8FAFC"/>
+                  <a:srgbClr val="0F172A"/>
                 </a:solidFill>
               </a:defRPr>
             </a:pPr>
@@ -8469,11 +8599,11 @@
           <a:p>
             <a:pPr>
               <a:spcBef>
-                <a:spcPts val="600"/>
+                <a:spcPts val="500"/>
               </a:spcBef>
               <a:defRPr sz="1000">
                 <a:solidFill>
-                  <a:srgbClr val="A0AEC0"/>
+                  <a:srgbClr val="475569"/>
                 </a:solidFill>
               </a:defRPr>
             </a:pPr>
@@ -8484,11 +8614,11 @@
           <a:p>
             <a:pPr>
               <a:spcBef>
-                <a:spcPts val="600"/>
+                <a:spcPts val="500"/>
               </a:spcBef>
               <a:defRPr sz="1000">
                 <a:solidFill>
-                  <a:srgbClr val="A0AEC0"/>
+                  <a:srgbClr val="475569"/>
                 </a:solidFill>
               </a:defRPr>
             </a:pPr>
@@ -8499,16 +8629,31 @@
           <a:p>
             <a:pPr>
               <a:spcBef>
-                <a:spcPts val="600"/>
+                <a:spcPts val="500"/>
               </a:spcBef>
               <a:defRPr sz="1000">
                 <a:solidFill>
-                  <a:srgbClr val="A0AEC0"/>
+                  <a:srgbClr val="475569"/>
                 </a:solidFill>
               </a:defRPr>
             </a:pPr>
             <a:r>
               <a:t>- Covers High Schools, Middle Schools &amp; Elementary</a:t>
+            </a:r>
+          </a:p>
+          <a:p>
+            <a:pPr>
+              <a:spcBef>
+                <a:spcPts val="500"/>
+              </a:spcBef>
+              <a:defRPr sz="1000">
+                <a:solidFill>
+                  <a:srgbClr val="475569"/>
+                </a:solidFill>
+              </a:defRPr>
+            </a:pPr>
+            <a:r>
+              <a:t>- Zero manual site measuring required</a:t>
             </a:r>
           </a:p>
         </p:txBody>
@@ -8528,11 +8673,11 @@
             <a:avLst/>
           </a:prstGeom>
           <a:solidFill>
-            <a:srgbClr val="131A2B"/>
+            <a:srgbClr val="FFFFFF"/>
           </a:solidFill>
           <a:ln w="12700">
             <a:solidFill>
-              <a:srgbClr val="222E4A"/>
+              <a:srgbClr val="E2E8F0"/>
             </a:solidFill>
           </a:ln>
         </p:spPr>
@@ -8573,7 +8718,7 @@
             <a:avLst/>
           </a:prstGeom>
           <a:solidFill>
-            <a:srgbClr val="10B981"/>
+            <a:srgbClr val="059669"/>
           </a:solidFill>
           <a:ln>
             <a:noFill/>
@@ -8624,9 +8769,9 @@
           <a:lstStyle/>
           <a:p>
             <a:pPr>
-              <a:defRPr sz="2400" b="1">
-                <a:solidFill>
-                  <a:srgbClr val="10B981"/>
+              <a:defRPr sz="2200" b="1">
+                <a:solidFill>
+                  <a:srgbClr val="059669"/>
                 </a:solidFill>
               </a:defRPr>
             </a:pPr>
@@ -8641,7 +8786,7 @@
               </a:spcBef>
               <a:defRPr sz="1100" b="1">
                 <a:solidFill>
-                  <a:srgbClr val="F8FAFC"/>
+                  <a:srgbClr val="0F172A"/>
                 </a:solidFill>
               </a:defRPr>
             </a:pPr>
@@ -8652,11 +8797,11 @@
           <a:p>
             <a:pPr>
               <a:spcBef>
-                <a:spcPts val="600"/>
+                <a:spcPts val="500"/>
               </a:spcBef>
               <a:defRPr sz="1000">
                 <a:solidFill>
-                  <a:srgbClr val="A0AEC0"/>
+                  <a:srgbClr val="475569"/>
                 </a:solidFill>
               </a:defRPr>
             </a:pPr>
@@ -8667,11 +8812,11 @@
           <a:p>
             <a:pPr>
               <a:spcBef>
-                <a:spcPts val="600"/>
+                <a:spcPts val="500"/>
               </a:spcBef>
               <a:defRPr sz="1000">
                 <a:solidFill>
-                  <a:srgbClr val="A0AEC0"/>
+                  <a:srgbClr val="475569"/>
                 </a:solidFill>
               </a:defRPr>
             </a:pPr>
@@ -8682,16 +8827,31 @@
           <a:p>
             <a:pPr>
               <a:spcBef>
-                <a:spcPts val="600"/>
+                <a:spcPts val="500"/>
               </a:spcBef>
               <a:defRPr sz="1000">
                 <a:solidFill>
-                  <a:srgbClr val="A0AEC0"/>
+                  <a:srgbClr val="475569"/>
                 </a:solidFill>
               </a:defRPr>
             </a:pPr>
             <a:r>
               <a:t>- Applies real local commercial electricity rates</a:t>
+            </a:r>
+          </a:p>
+          <a:p>
+            <a:pPr>
+              <a:spcBef>
+                <a:spcPts val="500"/>
+              </a:spcBef>
+              <a:defRPr sz="1000">
+                <a:solidFill>
+                  <a:srgbClr val="475569"/>
+                </a:solidFill>
+              </a:defRPr>
+            </a:pPr>
+            <a:r>
+              <a:t>- Calculates the exact federal cash reimbursement</a:t>
             </a:r>
           </a:p>
         </p:txBody>
@@ -8711,11 +8871,11 @@
             <a:avLst/>
           </a:prstGeom>
           <a:solidFill>
-            <a:srgbClr val="131A2B"/>
+            <a:srgbClr val="FFFFFF"/>
           </a:solidFill>
           <a:ln w="12700">
             <a:solidFill>
-              <a:srgbClr val="222E4A"/>
+              <a:srgbClr val="E2E8F0"/>
             </a:solidFill>
           </a:ln>
         </p:spPr>
@@ -8807,7 +8967,7 @@
           <a:lstStyle/>
           <a:p>
             <a:pPr>
-              <a:defRPr sz="2400" b="1">
+              <a:defRPr sz="2200" b="1">
                 <a:solidFill>
                   <a:srgbClr val="8C1515"/>
                 </a:solidFill>
@@ -8824,7 +8984,7 @@
               </a:spcBef>
               <a:defRPr sz="1100" b="1">
                 <a:solidFill>
-                  <a:srgbClr val="F8FAFC"/>
+                  <a:srgbClr val="0F172A"/>
                 </a:solidFill>
               </a:defRPr>
             </a:pPr>
@@ -8835,11 +8995,11 @@
           <a:p>
             <a:pPr>
               <a:spcBef>
-                <a:spcPts val="600"/>
+                <a:spcPts val="500"/>
               </a:spcBef>
               <a:defRPr sz="1000">
                 <a:solidFill>
-                  <a:srgbClr val="A0AEC0"/>
+                  <a:srgbClr val="475569"/>
                 </a:solidFill>
               </a:defRPr>
             </a:pPr>
@@ -8850,31 +9010,46 @@
           <a:p>
             <a:pPr>
               <a:spcBef>
-                <a:spcPts val="600"/>
+                <a:spcPts val="500"/>
               </a:spcBef>
               <a:defRPr sz="1000">
                 <a:solidFill>
-                  <a:srgbClr val="A0AEC0"/>
-                </a:solidFill>
-              </a:defRPr>
-            </a:pPr>
-            <a:r>
-              <a:t>- Calculates the exact federal cash grant</a:t>
-            </a:r>
-          </a:p>
-          <a:p>
-            <a:pPr>
-              <a:spcBef>
-                <a:spcPts val="600"/>
+                  <a:srgbClr val="475569"/>
+                </a:solidFill>
+              </a:defRPr>
+            </a:pPr>
+            <a:r>
+              <a:t>- Shows 25-year savings and simple payback</a:t>
+            </a:r>
+          </a:p>
+          <a:p>
+            <a:pPr>
+              <a:spcBef>
+                <a:spcPts val="500"/>
               </a:spcBef>
               <a:defRPr sz="1000">
                 <a:solidFill>
-                  <a:srgbClr val="A0AEC0"/>
+                  <a:srgbClr val="475569"/>
                 </a:solidFill>
               </a:defRPr>
             </a:pPr>
             <a:r>
               <a:t>- Includes a draft resolution ready for board votes</a:t>
+            </a:r>
+          </a:p>
+          <a:p>
+            <a:pPr>
+              <a:spcBef>
+                <a:spcPts val="500"/>
+              </a:spcBef>
+              <a:defRPr sz="1000">
+                <a:solidFill>
+                  <a:srgbClr val="475569"/>
+                </a:solidFill>
+              </a:defRPr>
+            </a:pPr>
+            <a:r>
+              <a:t>- Walk into your next school board meeting prepared</a:t>
             </a:r>
           </a:p>
         </p:txBody>
@@ -8894,11 +9069,11 @@
             <a:avLst/>
           </a:prstGeom>
           <a:solidFill>
-            <a:srgbClr val="131A2B"/>
+            <a:srgbClr val="FFFFFF"/>
           </a:solidFill>
           <a:ln w="12700">
             <a:solidFill>
-              <a:srgbClr val="38BDF8"/>
+              <a:srgbClr val="0284C7"/>
             </a:solidFill>
           </a:ln>
         </p:spPr>
@@ -8949,7 +9124,7 @@
             <a:pPr>
               <a:defRPr sz="900" b="1">
                 <a:solidFill>
-                  <a:srgbClr val="38BDF8"/>
+                  <a:srgbClr val="0284C7"/>
                 </a:solidFill>
               </a:defRPr>
             </a:pPr>
@@ -8964,7 +9139,7 @@
               </a:spcBef>
               <a:defRPr sz="1050" b="1">
                 <a:solidFill>
-                  <a:srgbClr val="F8FAFC"/>
+                  <a:srgbClr val="0F172A"/>
                 </a:solidFill>
               </a:defRPr>
             </a:pPr>
@@ -9007,7 +9182,7 @@
             <a:avLst/>
           </a:prstGeom>
           <a:solidFill>
-            <a:srgbClr val="0B0F19"/>
+            <a:srgbClr val="F8FAFC"/>
           </a:solidFill>
           <a:ln>
             <a:noFill/>
@@ -9050,10 +9225,12 @@
             <a:avLst/>
           </a:prstGeom>
           <a:solidFill>
-            <a:srgbClr val="0F172A"/>
+            <a:srgbClr val="F1F5F9"/>
           </a:solidFill>
-          <a:ln>
-            <a:noFill/>
+          <a:ln w="12700">
+            <a:solidFill>
+              <a:srgbClr val="E2E8F0"/>
+            </a:solidFill>
           </a:ln>
         </p:spPr>
         <p:style>
@@ -9155,7 +9332,7 @@
             <a:pPr>
               <a:defRPr sz="950">
                 <a:solidFill>
-                  <a:srgbClr val="A0AEC0"/>
+                  <a:srgbClr val="475569"/>
                 </a:solidFill>
               </a:defRPr>
             </a:pPr>
@@ -9190,7 +9367,7 @@
             <a:pPr algn="r">
               <a:defRPr sz="1000" b="1">
                 <a:solidFill>
-                  <a:srgbClr val="38BDF8"/>
+                  <a:srgbClr val="0284C7"/>
                 </a:solidFill>
               </a:defRPr>
             </a:pPr>
@@ -9215,7 +9392,7 @@
             <a:avLst/>
           </a:prstGeom>
           <a:solidFill>
-            <a:srgbClr val="38BDF8"/>
+            <a:srgbClr val="0284C7"/>
           </a:solidFill>
           <a:ln>
             <a:noFill/>
@@ -9268,7 +9445,7 @@
             <a:pPr>
               <a:defRPr sz="900" b="1">
                 <a:solidFill>
-                  <a:srgbClr val="38BDF8"/>
+                  <a:srgbClr val="0284C7"/>
                 </a:solidFill>
               </a:defRPr>
             </a:pPr>
@@ -9283,7 +9460,7 @@
               </a:spcBef>
               <a:defRPr sz="2200" b="1">
                 <a:solidFill>
-                  <a:srgbClr val="F8FAFC"/>
+                  <a:srgbClr val="0F172A"/>
                 </a:solidFill>
               </a:defRPr>
             </a:pPr>
@@ -9298,7 +9475,7 @@
               </a:spcBef>
               <a:defRPr sz="1100">
                 <a:solidFill>
-                  <a:srgbClr val="A0AEC0"/>
+                  <a:srgbClr val="475569"/>
                 </a:solidFill>
               </a:defRPr>
             </a:pPr>
@@ -9323,11 +9500,11 @@
             <a:avLst/>
           </a:prstGeom>
           <a:solidFill>
-            <a:srgbClr val="131A2B"/>
+            <a:srgbClr val="FFFFFF"/>
           </a:solidFill>
           <a:ln w="12700">
             <a:solidFill>
-              <a:srgbClr val="222E4A"/>
+              <a:srgbClr val="E2E8F0"/>
             </a:solidFill>
           </a:ln>
         </p:spPr>
@@ -9368,7 +9545,7 @@
             <a:avLst/>
           </a:prstGeom>
           <a:solidFill>
-            <a:srgbClr val="38BDF8"/>
+            <a:srgbClr val="0284C7"/>
           </a:solidFill>
           <a:ln>
             <a:noFill/>
@@ -9421,7 +9598,7 @@
             <a:pPr>
               <a:defRPr sz="3200" b="1">
                 <a:solidFill>
-                  <a:srgbClr val="38BDF8"/>
+                  <a:srgbClr val="0284C7"/>
                 </a:solidFill>
               </a:defRPr>
             </a:pPr>
@@ -9436,7 +9613,7 @@
               </a:spcBef>
               <a:defRPr sz="900" b="1">
                 <a:solidFill>
-                  <a:srgbClr val="F8FAFC"/>
+                  <a:srgbClr val="0F172A"/>
                 </a:solidFill>
               </a:defRPr>
             </a:pPr>
@@ -9447,11 +9624,11 @@
           <a:p>
             <a:pPr>
               <a:spcBef>
-                <a:spcPts val="600"/>
+                <a:spcPts val="500"/>
               </a:spcBef>
               <a:defRPr sz="1000">
                 <a:solidFill>
-                  <a:srgbClr val="A0AEC0"/>
+                  <a:srgbClr val="475569"/>
                 </a:solidFill>
               </a:defRPr>
             </a:pPr>
@@ -9462,11 +9639,11 @@
           <a:p>
             <a:pPr>
               <a:spcBef>
-                <a:spcPts val="600"/>
+                <a:spcPts val="500"/>
               </a:spcBef>
               <a:defRPr sz="1000">
                 <a:solidFill>
-                  <a:srgbClr val="A0AEC0"/>
+                  <a:srgbClr val="475569"/>
                 </a:solidFill>
               </a:defRPr>
             </a:pPr>
@@ -9477,16 +9654,31 @@
           <a:p>
             <a:pPr>
               <a:spcBef>
-                <a:spcPts val="600"/>
+                <a:spcPts val="500"/>
               </a:spcBef>
               <a:defRPr sz="1000">
                 <a:solidFill>
-                  <a:srgbClr val="A0AEC0"/>
+                  <a:srgbClr val="475569"/>
                 </a:solidFill>
               </a:defRPr>
             </a:pPr>
             <a:r>
               <a:t>- Preserves ADA accessible pathways and fire lanes</a:t>
+            </a:r>
+          </a:p>
+          <a:p>
+            <a:pPr>
+              <a:spcBef>
+                <a:spcPts val="500"/>
+              </a:spcBef>
+              <a:defRPr sz="1000">
+                <a:solidFill>
+                  <a:srgbClr val="475569"/>
+                </a:solidFill>
+              </a:defRPr>
+            </a:pPr>
+            <a:r>
+              <a:t>- Ensures parking remains convenient and functional</a:t>
             </a:r>
           </a:p>
         </p:txBody>
@@ -9506,11 +9698,11 @@
             <a:avLst/>
           </a:prstGeom>
           <a:solidFill>
-            <a:srgbClr val="131A2B"/>
+            <a:srgbClr val="FFFFFF"/>
           </a:solidFill>
           <a:ln w="12700">
             <a:solidFill>
-              <a:srgbClr val="222E4A"/>
+              <a:srgbClr val="E2E8F0"/>
             </a:solidFill>
           </a:ln>
         </p:spPr>
@@ -9551,7 +9743,7 @@
             <a:avLst/>
           </a:prstGeom>
           <a:solidFill>
-            <a:srgbClr val="38BDF8"/>
+            <a:srgbClr val="0284C7"/>
           </a:solidFill>
           <a:ln>
             <a:noFill/>
@@ -9604,7 +9796,7 @@
             <a:pPr>
               <a:defRPr sz="3200" b="1">
                 <a:solidFill>
-                  <a:srgbClr val="38BDF8"/>
+                  <a:srgbClr val="0284C7"/>
                 </a:solidFill>
               </a:defRPr>
             </a:pPr>
@@ -9619,7 +9811,7 @@
               </a:spcBef>
               <a:defRPr sz="900" b="1">
                 <a:solidFill>
-                  <a:srgbClr val="F8FAFC"/>
+                  <a:srgbClr val="0F172A"/>
                 </a:solidFill>
               </a:defRPr>
             </a:pPr>
@@ -9630,11 +9822,11 @@
           <a:p>
             <a:pPr>
               <a:spcBef>
-                <a:spcPts val="600"/>
+                <a:spcPts val="500"/>
               </a:spcBef>
               <a:defRPr sz="1000">
                 <a:solidFill>
-                  <a:srgbClr val="A0AEC0"/>
+                  <a:srgbClr val="475569"/>
                 </a:solidFill>
               </a:defRPr>
             </a:pPr>
@@ -9645,11 +9837,11 @@
           <a:p>
             <a:pPr>
               <a:spcBef>
-                <a:spcPts val="600"/>
+                <a:spcPts val="500"/>
               </a:spcBef>
               <a:defRPr sz="1000">
                 <a:solidFill>
-                  <a:srgbClr val="A0AEC0"/>
+                  <a:srgbClr val="475569"/>
                 </a:solidFill>
               </a:defRPr>
             </a:pPr>
@@ -9660,16 +9852,31 @@
           <a:p>
             <a:pPr>
               <a:spcBef>
-                <a:spcPts val="600"/>
+                <a:spcPts val="500"/>
               </a:spcBef>
               <a:defRPr sz="1000">
                 <a:solidFill>
-                  <a:srgbClr val="A0AEC0"/>
+                  <a:srgbClr val="475569"/>
                 </a:solidFill>
               </a:defRPr>
             </a:pPr>
             <a:r>
               <a:t>- Calibrated against active school arrays in Cupertino</a:t>
+            </a:r>
+          </a:p>
+          <a:p>
+            <a:pPr>
+              <a:spcBef>
+                <a:spcPts val="500"/>
+              </a:spcBef>
+              <a:defRPr sz="1000">
+                <a:solidFill>
+                  <a:srgbClr val="475569"/>
+                </a:solidFill>
+              </a:defRPr>
+            </a:pPr>
+            <a:r>
+              <a:t>- Uses industry-standard tier-1 monocrystalline panels</a:t>
             </a:r>
           </a:p>
         </p:txBody>
@@ -9689,11 +9896,11 @@
             <a:avLst/>
           </a:prstGeom>
           <a:solidFill>
-            <a:srgbClr val="131A2B"/>
+            <a:srgbClr val="FFFFFF"/>
           </a:solidFill>
           <a:ln w="12700">
             <a:solidFill>
-              <a:srgbClr val="222E4A"/>
+              <a:srgbClr val="E2E8F0"/>
             </a:solidFill>
           </a:ln>
         </p:spPr>
@@ -9734,7 +9941,7 @@
             <a:avLst/>
           </a:prstGeom>
           <a:solidFill>
-            <a:srgbClr val="10B981"/>
+            <a:srgbClr val="059669"/>
           </a:solidFill>
           <a:ln>
             <a:noFill/>
@@ -9787,7 +9994,7 @@
             <a:pPr>
               <a:defRPr sz="3200" b="1">
                 <a:solidFill>
-                  <a:srgbClr val="10B981"/>
+                  <a:srgbClr val="059669"/>
                 </a:solidFill>
               </a:defRPr>
             </a:pPr>
@@ -9802,7 +10009,7 @@
               </a:spcBef>
               <a:defRPr sz="900" b="1">
                 <a:solidFill>
-                  <a:srgbClr val="F8FAFC"/>
+                  <a:srgbClr val="0F172A"/>
                 </a:solidFill>
               </a:defRPr>
             </a:pPr>
@@ -9813,11 +10020,11 @@
           <a:p>
             <a:pPr>
               <a:spcBef>
-                <a:spcPts val="600"/>
+                <a:spcPts val="500"/>
               </a:spcBef>
               <a:defRPr sz="1000">
                 <a:solidFill>
-                  <a:srgbClr val="A0AEC0"/>
+                  <a:srgbClr val="475569"/>
                 </a:solidFill>
               </a:defRPr>
             </a:pPr>
@@ -9828,11 +10035,11 @@
           <a:p>
             <a:pPr>
               <a:spcBef>
-                <a:spcPts val="600"/>
+                <a:spcPts val="500"/>
               </a:spcBef>
               <a:defRPr sz="1000">
                 <a:solidFill>
-                  <a:srgbClr val="A0AEC0"/>
+                  <a:srgbClr val="475569"/>
                 </a:solidFill>
               </a:defRPr>
             </a:pPr>
@@ -9843,16 +10050,31 @@
           <a:p>
             <a:pPr>
               <a:spcBef>
-                <a:spcPts val="600"/>
+                <a:spcPts val="500"/>
               </a:spcBef>
               <a:defRPr sz="1000">
                 <a:solidFill>
-                  <a:srgbClr val="A0AEC0"/>
+                  <a:srgbClr val="475569"/>
                 </a:solidFill>
               </a:defRPr>
             </a:pPr>
             <a:r>
               <a:t>- Includes instant smart backup so it never crashes</a:t>
+            </a:r>
+          </a:p>
+          <a:p>
+            <a:pPr>
+              <a:spcBef>
+                <a:spcPts val="500"/>
+              </a:spcBef>
+              <a:defRPr sz="1000">
+                <a:solidFill>
+                  <a:srgbClr val="475569"/>
+                </a:solidFill>
+              </a:defRPr>
+            </a:pPr>
+            <a:r>
+              <a:t>- Matches professional engineering precision</a:t>
             </a:r>
           </a:p>
         </p:txBody>
@@ -9872,11 +10094,11 @@
             <a:avLst/>
           </a:prstGeom>
           <a:solidFill>
-            <a:srgbClr val="131A2B"/>
+            <a:srgbClr val="FFFFFF"/>
           </a:solidFill>
           <a:ln w="12700">
             <a:solidFill>
-              <a:srgbClr val="38BDF8"/>
+              <a:srgbClr val="0284C7"/>
             </a:solidFill>
           </a:ln>
         </p:spPr>
@@ -9927,7 +10149,7 @@
             <a:pPr>
               <a:defRPr sz="900" b="1">
                 <a:solidFill>
-                  <a:srgbClr val="38BDF8"/>
+                  <a:srgbClr val="0284C7"/>
                 </a:solidFill>
               </a:defRPr>
             </a:pPr>
@@ -9942,7 +10164,7 @@
               </a:spcBef>
               <a:defRPr sz="1050" b="1">
                 <a:solidFill>
-                  <a:srgbClr val="F8FAFC"/>
+                  <a:srgbClr val="0F172A"/>
                 </a:solidFill>
               </a:defRPr>
             </a:pPr>
@@ -9985,7 +10207,7 @@
             <a:avLst/>
           </a:prstGeom>
           <a:solidFill>
-            <a:srgbClr val="0B0F19"/>
+            <a:srgbClr val="F8FAFC"/>
           </a:solidFill>
           <a:ln>
             <a:noFill/>
@@ -10028,10 +10250,12 @@
             <a:avLst/>
           </a:prstGeom>
           <a:solidFill>
-            <a:srgbClr val="0F172A"/>
+            <a:srgbClr val="F1F5F9"/>
           </a:solidFill>
-          <a:ln>
-            <a:noFill/>
+          <a:ln w="12700">
+            <a:solidFill>
+              <a:srgbClr val="E2E8F0"/>
+            </a:solidFill>
           </a:ln>
         </p:spPr>
         <p:style>
@@ -10133,7 +10357,7 @@
             <a:pPr>
               <a:defRPr sz="950">
                 <a:solidFill>
-                  <a:srgbClr val="A0AEC0"/>
+                  <a:srgbClr val="475569"/>
                 </a:solidFill>
               </a:defRPr>
             </a:pPr>
@@ -10168,7 +10392,7 @@
             <a:pPr algn="r">
               <a:defRPr sz="1000" b="1">
                 <a:solidFill>
-                  <a:srgbClr val="38BDF8"/>
+                  <a:srgbClr val="0284C7"/>
                 </a:solidFill>
               </a:defRPr>
             </a:pPr>
@@ -10193,7 +10417,7 @@
             <a:avLst/>
           </a:prstGeom>
           <a:solidFill>
-            <a:srgbClr val="38BDF8"/>
+            <a:srgbClr val="0284C7"/>
           </a:solidFill>
           <a:ln>
             <a:noFill/>
@@ -10246,7 +10470,7 @@
             <a:pPr>
               <a:defRPr sz="900" b="1">
                 <a:solidFill>
-                  <a:srgbClr val="38BDF8"/>
+                  <a:srgbClr val="0284C7"/>
                 </a:solidFill>
               </a:defRPr>
             </a:pPr>
@@ -10261,7 +10485,7 @@
               </a:spcBef>
               <a:defRPr sz="2200" b="1">
                 <a:solidFill>
-                  <a:srgbClr val="F8FAFC"/>
+                  <a:srgbClr val="0F172A"/>
                 </a:solidFill>
               </a:defRPr>
             </a:pPr>
@@ -10276,7 +10500,7 @@
               </a:spcBef>
               <a:defRPr sz="1100">
                 <a:solidFill>
-                  <a:srgbClr val="A0AEC0"/>
+                  <a:srgbClr val="475569"/>
                 </a:solidFill>
               </a:defRPr>
             </a:pPr>
@@ -10301,11 +10525,11 @@
             <a:avLst/>
           </a:prstGeom>
           <a:solidFill>
-            <a:srgbClr val="131A2B"/>
+            <a:srgbClr val="FFFFFF"/>
           </a:solidFill>
           <a:ln w="12700">
             <a:solidFill>
-              <a:srgbClr val="222E4A"/>
+              <a:srgbClr val="E2E8F0"/>
             </a:solidFill>
           </a:ln>
         </p:spPr>
@@ -10346,7 +10570,7 @@
             <a:avLst/>
           </a:prstGeom>
           <a:solidFill>
-            <a:srgbClr val="10B981"/>
+            <a:srgbClr val="059669"/>
           </a:solidFill>
           <a:ln>
             <a:noFill/>
@@ -10399,7 +10623,7 @@
             <a:pPr>
               <a:defRPr sz="1100" b="1">
                 <a:solidFill>
-                  <a:srgbClr val="10B981"/>
+                  <a:srgbClr val="059669"/>
                 </a:solidFill>
               </a:defRPr>
             </a:pPr>
@@ -10414,7 +10638,7 @@
               </a:spcBef>
               <a:defRPr sz="900" b="1">
                 <a:solidFill>
-                  <a:srgbClr val="718096"/>
+                  <a:srgbClr val="94A3B8"/>
                 </a:solidFill>
               </a:defRPr>
             </a:pPr>
@@ -10429,12 +10653,12 @@
               </a:spcBef>
               <a:defRPr sz="3600" b="1">
                 <a:solidFill>
-                  <a:srgbClr val="10B981"/>
-                </a:solidFill>
-              </a:defRPr>
-            </a:pPr>
-            <a:r>
-              <a:t>$145,000 / yr</a:t>
+                  <a:srgbClr val="059669"/>
+                </a:solidFill>
+              </a:defRPr>
+            </a:pPr>
+            <a:r>
+              <a:t>+$145,000 / yr</a:t>
             </a:r>
           </a:p>
           <a:p>
@@ -10444,12 +10668,12 @@
               </a:spcBef>
               <a:defRPr sz="1000" b="0">
                 <a:solidFill>
-                  <a:srgbClr val="A0AEC0"/>
-                </a:solidFill>
-              </a:defRPr>
-            </a:pPr>
-            <a:r>
-              <a:t>- Completed 550 kW solar carports across student lot</a:t>
+                  <a:srgbClr val="475569"/>
+                </a:solidFill>
+              </a:defRPr>
+            </a:pPr>
+            <a:r>
+              <a:t>- Completed 550 kW solar carports across student parking</a:t>
             </a:r>
           </a:p>
           <a:p>
@@ -10459,7 +10683,7 @@
               </a:spcBef>
               <a:defRPr sz="1000" b="0">
                 <a:solidFill>
-                  <a:srgbClr val="A0AEC0"/>
+                  <a:srgbClr val="475569"/>
                 </a:solidFill>
               </a:defRPr>
             </a:pPr>
@@ -10474,12 +10698,12 @@
               </a:spcBef>
               <a:defRPr sz="1000" b="0">
                 <a:solidFill>
-                  <a:srgbClr val="A0AEC0"/>
-                </a:solidFill>
-              </a:defRPr>
-            </a:pPr>
-            <a:r>
-              <a:t>- Our model predicted $145K savings; actual FUHSD bill records show $139K!</a:t>
+                  <a:srgbClr val="475569"/>
+                </a:solidFill>
+              </a:defRPr>
+            </a:pPr>
+            <a:r>
+              <a:t>- Our model predicted $145K savings; actual published bills show $139K!</a:t>
             </a:r>
           </a:p>
           <a:p>
@@ -10489,12 +10713,27 @@
               </a:spcBef>
               <a:defRPr sz="1000" b="1">
                 <a:solidFill>
-                  <a:srgbClr val="F8FAFC"/>
+                  <a:srgbClr val="0F172A"/>
                 </a:solidFill>
               </a:defRPr>
             </a:pPr>
             <a:r>
               <a:t>- Empirical accuracy within 4.17% of actual utility bills</a:t>
+            </a:r>
+          </a:p>
+          <a:p>
+            <a:pPr>
+              <a:spcBef>
+                <a:spcPts val="1000"/>
+              </a:spcBef>
+              <a:defRPr sz="950" b="1">
+                <a:solidFill>
+                  <a:srgbClr val="059669"/>
+                </a:solidFill>
+              </a:defRPr>
+            </a:pPr>
+            <a:r>
+              <a:t>VALIDATION PROOF: The software matches real-world utility bills.</a:t>
             </a:r>
           </a:p>
         </p:txBody>
@@ -10514,11 +10753,11 @@
             <a:avLst/>
           </a:prstGeom>
           <a:solidFill>
-            <a:srgbClr val="131A2B"/>
+            <a:srgbClr val="FFFFFF"/>
           </a:solidFill>
           <a:ln w="12700">
             <a:solidFill>
-              <a:srgbClr val="222E4A"/>
+              <a:srgbClr val="E2E8F0"/>
             </a:solidFill>
           </a:ln>
         </p:spPr>
@@ -10559,7 +10798,7 @@
             <a:avLst/>
           </a:prstGeom>
           <a:solidFill>
-            <a:srgbClr val="EF4444"/>
+            <a:srgbClr val="DC2626"/>
           </a:solidFill>
           <a:ln>
             <a:noFill/>
@@ -10612,7 +10851,7 @@
             <a:pPr>
               <a:defRPr sz="1100" b="1">
                 <a:solidFill>
-                  <a:srgbClr val="EF4444"/>
+                  <a:srgbClr val="DC2626"/>
                 </a:solidFill>
               </a:defRPr>
             </a:pPr>
@@ -10627,7 +10866,7 @@
               </a:spcBef>
               <a:defRPr sz="900" b="1">
                 <a:solidFill>
-                  <a:srgbClr val="718096"/>
+                  <a:srgbClr val="94A3B8"/>
                 </a:solidFill>
               </a:defRPr>
             </a:pPr>
@@ -10642,7 +10881,7 @@
               </a:spcBef>
               <a:defRPr sz="3600" b="1">
                 <a:solidFill>
-                  <a:srgbClr val="EF4444"/>
+                  <a:srgbClr val="DC2626"/>
                 </a:solidFill>
               </a:defRPr>
             </a:pPr>
@@ -10657,7 +10896,7 @@
               </a:spcBef>
               <a:defRPr sz="1000" b="0">
                 <a:solidFill>
-                  <a:srgbClr val="A0AEC0"/>
+                  <a:srgbClr val="475569"/>
                 </a:solidFill>
               </a:defRPr>
             </a:pPr>
@@ -10672,7 +10911,7 @@
               </a:spcBef>
               <a:defRPr sz="1000" b="0">
                 <a:solidFill>
-                  <a:srgbClr val="A0AEC0"/>
+                  <a:srgbClr val="475569"/>
                 </a:solidFill>
               </a:defRPr>
             </a:pPr>
@@ -10687,7 +10926,7 @@
               </a:spcBef>
               <a:defRPr sz="1000" b="0">
                 <a:solidFill>
-                  <a:srgbClr val="A0AEC0"/>
+                  <a:srgbClr val="475569"/>
                 </a:solidFill>
               </a:defRPr>
             </a:pPr>
@@ -10702,7 +10941,7 @@
               </a:spcBef>
               <a:defRPr sz="1000" b="1">
                 <a:solidFill>
-                  <a:srgbClr val="F8FAFC"/>
+                  <a:srgbClr val="0F172A"/>
                 </a:solidFill>
               </a:defRPr>
             </a:pPr>
@@ -10717,7 +10956,7 @@
               </a:spcBef>
               <a:defRPr sz="1050" b="1">
                 <a:solidFill>
-                  <a:srgbClr val="F59E0B"/>
+                  <a:srgbClr val="D97706"/>
                 </a:solidFill>
               </a:defRPr>
             </a:pPr>
@@ -10760,7 +10999,7 @@
             <a:avLst/>
           </a:prstGeom>
           <a:solidFill>
-            <a:srgbClr val="0B0F19"/>
+            <a:srgbClr val="F8FAFC"/>
           </a:solidFill>
           <a:ln>
             <a:noFill/>
@@ -10803,10 +11042,12 @@
             <a:avLst/>
           </a:prstGeom>
           <a:solidFill>
-            <a:srgbClr val="0F172A"/>
+            <a:srgbClr val="F1F5F9"/>
           </a:solidFill>
-          <a:ln>
-            <a:noFill/>
+          <a:ln w="12700">
+            <a:solidFill>
+              <a:srgbClr val="E2E8F0"/>
+            </a:solidFill>
           </a:ln>
         </p:spPr>
         <p:style>
@@ -10908,7 +11149,7 @@
             <a:pPr>
               <a:defRPr sz="950">
                 <a:solidFill>
-                  <a:srgbClr val="A0AEC0"/>
+                  <a:srgbClr val="475569"/>
                 </a:solidFill>
               </a:defRPr>
             </a:pPr>
@@ -10943,7 +11184,7 @@
             <a:pPr algn="r">
               <a:defRPr sz="1000" b="1">
                 <a:solidFill>
-                  <a:srgbClr val="38BDF8"/>
+                  <a:srgbClr val="0284C7"/>
                 </a:solidFill>
               </a:defRPr>
             </a:pPr>
@@ -10968,7 +11209,7 @@
             <a:avLst/>
           </a:prstGeom>
           <a:solidFill>
-            <a:srgbClr val="38BDF8"/>
+            <a:srgbClr val="0284C7"/>
           </a:solidFill>
           <a:ln>
             <a:noFill/>
@@ -11021,7 +11262,7 @@
             <a:pPr>
               <a:defRPr sz="900" b="1">
                 <a:solidFill>
-                  <a:srgbClr val="38BDF8"/>
+                  <a:srgbClr val="0284C7"/>
                 </a:solidFill>
               </a:defRPr>
             </a:pPr>
@@ -11036,7 +11277,7 @@
               </a:spcBef>
               <a:defRPr sz="2200" b="1">
                 <a:solidFill>
-                  <a:srgbClr val="F8FAFC"/>
+                  <a:srgbClr val="0F172A"/>
                 </a:solidFill>
               </a:defRPr>
             </a:pPr>
@@ -11051,7 +11292,7 @@
               </a:spcBef>
               <a:defRPr sz="1100">
                 <a:solidFill>
-                  <a:srgbClr val="A0AEC0"/>
+                  <a:srgbClr val="475569"/>
                 </a:solidFill>
               </a:defRPr>
             </a:pPr>
@@ -11076,11 +11317,11 @@
             <a:avLst/>
           </a:prstGeom>
           <a:solidFill>
-            <a:srgbClr val="131A2B"/>
+            <a:srgbClr val="FFFFFF"/>
           </a:solidFill>
           <a:ln w="12700">
             <a:solidFill>
-              <a:srgbClr val="222E4A"/>
+              <a:srgbClr val="E2E8F0"/>
             </a:solidFill>
           </a:ln>
         </p:spPr>
@@ -11121,7 +11362,7 @@
             <a:avLst/>
           </a:prstGeom>
           <a:solidFill>
-            <a:srgbClr val="10B981"/>
+            <a:srgbClr val="059669"/>
           </a:solidFill>
           <a:ln>
             <a:noFill/>
@@ -11172,9 +11413,9 @@
           <a:lstStyle/>
           <a:p>
             <a:pPr>
-              <a:defRPr sz="3000" b="1">
-                <a:solidFill>
-                  <a:srgbClr val="10B981"/>
+              <a:defRPr sz="2800" b="1">
+                <a:solidFill>
+                  <a:srgbClr val="059669"/>
                 </a:solidFill>
               </a:defRPr>
             </a:pPr>
@@ -11189,7 +11430,7 @@
               </a:spcBef>
               <a:defRPr sz="850" b="1">
                 <a:solidFill>
-                  <a:srgbClr val="F8FAFC"/>
+                  <a:srgbClr val="0F172A"/>
                 </a:solidFill>
               </a:defRPr>
             </a:pPr>
@@ -11200,11 +11441,11 @@
           <a:p>
             <a:pPr>
               <a:spcBef>
-                <a:spcPts val="600"/>
+                <a:spcPts val="500"/>
               </a:spcBef>
               <a:defRPr sz="950">
                 <a:solidFill>
-                  <a:srgbClr val="A0AEC0"/>
+                  <a:srgbClr val="475569"/>
                 </a:solidFill>
               </a:defRPr>
             </a:pPr>
@@ -11215,31 +11456,46 @@
           <a:p>
             <a:pPr>
               <a:spcBef>
-                <a:spcPts val="600"/>
+                <a:spcPts val="500"/>
               </a:spcBef>
               <a:defRPr sz="950">
                 <a:solidFill>
-                  <a:srgbClr val="A0AEC0"/>
-                </a:solidFill>
-              </a:defRPr>
-            </a:pPr>
-            <a:r>
-              <a:t>- Drops from 6+ years thanks to Direct Pay</a:t>
-            </a:r>
-          </a:p>
-          <a:p>
-            <a:pPr>
-              <a:spcBef>
-                <a:spcPts val="600"/>
+                  <a:srgbClr val="475569"/>
+                </a:solidFill>
+              </a:defRPr>
+            </a:pPr>
+            <a:r>
+              <a:t>- Drops from 6+ years with Direct Pay</a:t>
+            </a:r>
+          </a:p>
+          <a:p>
+            <a:pPr>
+              <a:spcBef>
+                <a:spcPts val="500"/>
               </a:spcBef>
               <a:defRPr sz="950">
                 <a:solidFill>
-                  <a:srgbClr val="A0AEC0"/>
-                </a:solidFill>
-              </a:defRPr>
-            </a:pPr>
-            <a:r>
-              <a:t>- Faster than almost any school bond project</a:t>
+                  <a:srgbClr val="475569"/>
+                </a:solidFill>
+              </a:defRPr>
+            </a:pPr>
+            <a:r>
+              <a:t>- Faster than school bond projects</a:t>
+            </a:r>
+          </a:p>
+          <a:p>
+            <a:pPr>
+              <a:spcBef>
+                <a:spcPts val="500"/>
+              </a:spcBef>
+              <a:defRPr sz="950">
+                <a:solidFill>
+                  <a:srgbClr val="475569"/>
+                </a:solidFill>
+              </a:defRPr>
+            </a:pPr>
+            <a:r>
+              <a:t>- Delivers net positive cashflow</a:t>
             </a:r>
           </a:p>
         </p:txBody>
@@ -11259,11 +11515,11 @@
             <a:avLst/>
           </a:prstGeom>
           <a:solidFill>
-            <a:srgbClr val="131A2B"/>
+            <a:srgbClr val="FFFFFF"/>
           </a:solidFill>
           <a:ln w="12700">
             <a:solidFill>
-              <a:srgbClr val="222E4A"/>
+              <a:srgbClr val="E2E8F0"/>
             </a:solidFill>
           </a:ln>
         </p:spPr>
@@ -11304,7 +11560,7 @@
             <a:avLst/>
           </a:prstGeom>
           <a:solidFill>
-            <a:srgbClr val="38BDF8"/>
+            <a:srgbClr val="0284C7"/>
           </a:solidFill>
           <a:ln>
             <a:noFill/>
@@ -11355,9 +11611,9 @@
           <a:lstStyle/>
           <a:p>
             <a:pPr>
-              <a:defRPr sz="3000" b="1">
-                <a:solidFill>
-                  <a:srgbClr val="38BDF8"/>
+              <a:defRPr sz="2800" b="1">
+                <a:solidFill>
+                  <a:srgbClr val="0284C7"/>
                 </a:solidFill>
               </a:defRPr>
             </a:pPr>
@@ -11372,7 +11628,7 @@
               </a:spcBef>
               <a:defRPr sz="850" b="1">
                 <a:solidFill>
-                  <a:srgbClr val="F8FAFC"/>
+                  <a:srgbClr val="0F172A"/>
                 </a:solidFill>
               </a:defRPr>
             </a:pPr>
@@ -11383,46 +11639,61 @@
           <a:p>
             <a:pPr>
               <a:spcBef>
-                <a:spcPts val="600"/>
+                <a:spcPts val="500"/>
               </a:spcBef>
               <a:defRPr sz="950">
                 <a:solidFill>
-                  <a:srgbClr val="A0AEC0"/>
-                </a:solidFill>
-              </a:defRPr>
-            </a:pPr>
-            <a:r>
-              <a:t>- Direct cash reimbursement from IRS</a:t>
-            </a:r>
-          </a:p>
-          <a:p>
-            <a:pPr>
-              <a:spcBef>
-                <a:spcPts val="600"/>
+                  <a:srgbClr val="475569"/>
+                </a:solidFill>
+              </a:defRPr>
+            </a:pPr>
+            <a:r>
+              <a:t>- Direct cash grant from the IRS</a:t>
+            </a:r>
+          </a:p>
+          <a:p>
+            <a:pPr>
+              <a:spcBef>
+                <a:spcPts val="500"/>
               </a:spcBef>
               <a:defRPr sz="950">
                 <a:solidFill>
-                  <a:srgbClr val="A0AEC0"/>
-                </a:solidFill>
-              </a:defRPr>
-            </a:pPr>
-            <a:r>
-              <a:t>- Covers 30% to 50% of the total canopy cost</a:t>
-            </a:r>
-          </a:p>
-          <a:p>
-            <a:pPr>
-              <a:spcBef>
-                <a:spcPts val="600"/>
+                  <a:srgbClr val="475569"/>
+                </a:solidFill>
+              </a:defRPr>
+            </a:pPr>
+            <a:r>
+              <a:t>- Covers 30% to 50% of total cost</a:t>
+            </a:r>
+          </a:p>
+          <a:p>
+            <a:pPr>
+              <a:spcBef>
+                <a:spcPts val="500"/>
               </a:spcBef>
               <a:defRPr sz="950">
                 <a:solidFill>
-                  <a:srgbClr val="A0AEC0"/>
-                </a:solidFill>
-              </a:defRPr>
-            </a:pPr>
-            <a:r>
-              <a:t>- Paid directly to the district treasury</a:t>
+                  <a:srgbClr val="475569"/>
+                </a:solidFill>
+              </a:defRPr>
+            </a:pPr>
+            <a:r>
+              <a:t>- Paid to district treasury</a:t>
+            </a:r>
+          </a:p>
+          <a:p>
+            <a:pPr>
+              <a:spcBef>
+                <a:spcPts val="500"/>
+              </a:spcBef>
+              <a:defRPr sz="950">
+                <a:solidFill>
+                  <a:srgbClr val="475569"/>
+                </a:solidFill>
+              </a:defRPr>
+            </a:pPr>
+            <a:r>
+              <a:t>- No bond measure required</a:t>
             </a:r>
           </a:p>
         </p:txBody>
@@ -11442,11 +11713,11 @@
             <a:avLst/>
           </a:prstGeom>
           <a:solidFill>
-            <a:srgbClr val="131A2B"/>
+            <a:srgbClr val="FFFFFF"/>
           </a:solidFill>
           <a:ln w="12700">
             <a:solidFill>
-              <a:srgbClr val="222E4A"/>
+              <a:srgbClr val="E2E8F0"/>
             </a:solidFill>
           </a:ln>
         </p:spPr>
@@ -11487,7 +11758,7 @@
             <a:avLst/>
           </a:prstGeom>
           <a:solidFill>
-            <a:srgbClr val="10B981"/>
+            <a:srgbClr val="059669"/>
           </a:solidFill>
           <a:ln>
             <a:noFill/>
@@ -11538,9 +11809,9 @@
           <a:lstStyle/>
           <a:p>
             <a:pPr>
-              <a:defRPr sz="3000" b="1">
-                <a:solidFill>
-                  <a:srgbClr val="10B981"/>
+              <a:defRPr sz="2800" b="1">
+                <a:solidFill>
+                  <a:srgbClr val="059669"/>
                 </a:solidFill>
               </a:defRPr>
             </a:pPr>
@@ -11555,57 +11826,72 @@
               </a:spcBef>
               <a:defRPr sz="850" b="1">
                 <a:solidFill>
-                  <a:srgbClr val="F8FAFC"/>
-                </a:solidFill>
-              </a:defRPr>
-            </a:pPr>
-            <a:r>
-              <a:t>ANNUAL BILL SAVINGS</a:t>
-            </a:r>
-          </a:p>
-          <a:p>
-            <a:pPr>
-              <a:spcBef>
-                <a:spcPts val="600"/>
+                  <a:srgbClr val="0F172A"/>
+                </a:solidFill>
+              </a:defRPr>
+            </a:pPr>
+            <a:r>
+              <a:t>ANNUAL SAVINGS</a:t>
+            </a:r>
+          </a:p>
+          <a:p>
+            <a:pPr>
+              <a:spcBef>
+                <a:spcPts val="500"/>
               </a:spcBef>
               <a:defRPr sz="950">
                 <a:solidFill>
-                  <a:srgbClr val="A0AEC0"/>
-                </a:solidFill>
-              </a:defRPr>
-            </a:pPr>
-            <a:r>
-              <a:t>- Clean solar power offsets expensive peak grid rates</a:t>
-            </a:r>
-          </a:p>
-          <a:p>
-            <a:pPr>
-              <a:spcBef>
-                <a:spcPts val="600"/>
+                  <a:srgbClr val="475569"/>
+                </a:solidFill>
+              </a:defRPr>
+            </a:pPr>
+            <a:r>
+              <a:t>- Avoided retail power bills</a:t>
+            </a:r>
+          </a:p>
+          <a:p>
+            <a:pPr>
+              <a:spcBef>
+                <a:spcPts val="500"/>
               </a:spcBef>
               <a:defRPr sz="950">
                 <a:solidFill>
-                  <a:srgbClr val="A0AEC0"/>
-                </a:solidFill>
-              </a:defRPr>
-            </a:pPr>
-            <a:r>
-              <a:t>- Protects district from rising utility prices</a:t>
-            </a:r>
-          </a:p>
-          <a:p>
-            <a:pPr>
-              <a:spcBef>
-                <a:spcPts val="600"/>
+                  <a:srgbClr val="475569"/>
+                </a:solidFill>
+              </a:defRPr>
+            </a:pPr>
+            <a:r>
+              <a:t>- Protects against rising PG&amp;E rates</a:t>
+            </a:r>
+          </a:p>
+          <a:p>
+            <a:pPr>
+              <a:spcBef>
+                <a:spcPts val="500"/>
               </a:spcBef>
               <a:defRPr sz="950">
                 <a:solidFill>
-                  <a:srgbClr val="A0AEC0"/>
-                </a:solidFill>
-              </a:defRPr>
-            </a:pPr>
-            <a:r>
-              <a:t>- Savings start the first month it's turned on</a:t>
+                  <a:srgbClr val="475569"/>
+                </a:solidFill>
+              </a:defRPr>
+            </a:pPr>
+            <a:r>
+              <a:t>- Savings start in Month 1</a:t>
+            </a:r>
+          </a:p>
+          <a:p>
+            <a:pPr>
+              <a:spcBef>
+                <a:spcPts val="500"/>
+              </a:spcBef>
+              <a:defRPr sz="950">
+                <a:solidFill>
+                  <a:srgbClr val="475569"/>
+                </a:solidFill>
+              </a:defRPr>
+            </a:pPr>
+            <a:r>
+              <a:t>- Funds instructional resources</a:t>
             </a:r>
           </a:p>
         </p:txBody>
@@ -11625,11 +11911,11 @@
             <a:avLst/>
           </a:prstGeom>
           <a:solidFill>
-            <a:srgbClr val="131A2B"/>
+            <a:srgbClr val="FFFFFF"/>
           </a:solidFill>
           <a:ln w="12700">
             <a:solidFill>
-              <a:srgbClr val="222E4A"/>
+              <a:srgbClr val="E2E8F0"/>
             </a:solidFill>
           </a:ln>
         </p:spPr>
@@ -11670,7 +11956,7 @@
             <a:avLst/>
           </a:prstGeom>
           <a:solidFill>
-            <a:srgbClr val="F59E0B"/>
+            <a:srgbClr val="D97706"/>
           </a:solidFill>
           <a:ln>
             <a:noFill/>
@@ -11721,9 +12007,9 @@
           <a:lstStyle/>
           <a:p>
             <a:pPr>
-              <a:defRPr sz="3000" b="1">
-                <a:solidFill>
-                  <a:srgbClr val="F59E0B"/>
+              <a:defRPr sz="2800" b="1">
+                <a:solidFill>
+                  <a:srgbClr val="D97706"/>
                 </a:solidFill>
               </a:defRPr>
             </a:pPr>
@@ -11738,7 +12024,7 @@
               </a:spcBef>
               <a:defRPr sz="850" b="1">
                 <a:solidFill>
-                  <a:srgbClr val="F8FAFC"/>
+                  <a:srgbClr val="0F172A"/>
                 </a:solidFill>
               </a:defRPr>
             </a:pPr>
@@ -11749,46 +12035,61 @@
           <a:p>
             <a:pPr>
               <a:spcBef>
-                <a:spcPts val="600"/>
+                <a:spcPts val="500"/>
               </a:spcBef>
               <a:defRPr sz="950">
                 <a:solidFill>
-                  <a:srgbClr val="A0AEC0"/>
-                </a:solidFill>
-              </a:defRPr>
-            </a:pPr>
-            <a:r>
-              <a:t>- Total cumulative net savings over 25 years</a:t>
-            </a:r>
-          </a:p>
-          <a:p>
-            <a:pPr>
-              <a:spcBef>
-                <a:spcPts val="600"/>
+                  <a:srgbClr val="475569"/>
+                </a:solidFill>
+              </a:defRPr>
+            </a:pPr>
+            <a:r>
+              <a:t>- Cumulative net savings</a:t>
+            </a:r>
+          </a:p>
+          <a:p>
+            <a:pPr>
+              <a:spcBef>
+                <a:spcPts val="500"/>
               </a:spcBef>
               <a:defRPr sz="950">
                 <a:solidFill>
-                  <a:srgbClr val="A0AEC0"/>
-                </a:solidFill>
-              </a:defRPr>
-            </a:pPr>
-            <a:r>
-              <a:t>- Accounts for panel aging and maintenance costs</a:t>
-            </a:r>
-          </a:p>
-          <a:p>
-            <a:pPr>
-              <a:spcBef>
-                <a:spcPts val="600"/>
+                  <a:srgbClr val="475569"/>
+                </a:solidFill>
+              </a:defRPr>
+            </a:pPr>
+            <a:r>
+              <a:t>- Accounts for maintenance</a:t>
+            </a:r>
+          </a:p>
+          <a:p>
+            <a:pPr>
+              <a:spcBef>
+                <a:spcPts val="500"/>
               </a:spcBef>
               <a:defRPr sz="950">
                 <a:solidFill>
-                  <a:srgbClr val="A0AEC0"/>
-                </a:solidFill>
-              </a:defRPr>
-            </a:pPr>
-            <a:r>
-              <a:t>- Permanent long-term funding for school programs</a:t>
+                  <a:srgbClr val="475569"/>
+                </a:solidFill>
+              </a:defRPr>
+            </a:pPr>
+            <a:r>
+              <a:t>- Permanent classroom cash</a:t>
+            </a:r>
+          </a:p>
+          <a:p>
+            <a:pPr>
+              <a:spcBef>
+                <a:spcPts val="500"/>
+              </a:spcBef>
+              <a:defRPr sz="950">
+                <a:solidFill>
+                  <a:srgbClr val="475569"/>
+                </a:solidFill>
+              </a:defRPr>
+            </a:pPr>
+            <a:r>
+              <a:t>- Zero school bond tax hikes</a:t>
             </a:r>
           </a:p>
         </p:txBody>
@@ -11808,11 +12109,11 @@
             <a:avLst/>
           </a:prstGeom>
           <a:solidFill>
-            <a:srgbClr val="131A2B"/>
+            <a:srgbClr val="FFFFFF"/>
           </a:solidFill>
           <a:ln w="12700">
             <a:solidFill>
-              <a:srgbClr val="10B981"/>
+              <a:srgbClr val="059669"/>
             </a:solidFill>
           </a:ln>
         </p:spPr>
@@ -11863,7 +12164,7 @@
             <a:pPr>
               <a:defRPr sz="900" b="1">
                 <a:solidFill>
-                  <a:srgbClr val="10B981"/>
+                  <a:srgbClr val="059669"/>
                 </a:solidFill>
               </a:defRPr>
             </a:pPr>
@@ -11878,7 +12179,7 @@
               </a:spcBef>
               <a:defRPr sz="1050" b="1">
                 <a:solidFill>
-                  <a:srgbClr val="F8FAFC"/>
+                  <a:srgbClr val="0F172A"/>
                 </a:solidFill>
               </a:defRPr>
             </a:pPr>
@@ -11921,7 +12222,7 @@
             <a:avLst/>
           </a:prstGeom>
           <a:solidFill>
-            <a:srgbClr val="0B0F19"/>
+            <a:srgbClr val="F8FAFC"/>
           </a:solidFill>
           <a:ln>
             <a:noFill/>
@@ -11964,10 +12265,12 @@
             <a:avLst/>
           </a:prstGeom>
           <a:solidFill>
-            <a:srgbClr val="0F172A"/>
+            <a:srgbClr val="F1F5F9"/>
           </a:solidFill>
-          <a:ln>
-            <a:noFill/>
+          <a:ln w="12700">
+            <a:solidFill>
+              <a:srgbClr val="E2E8F0"/>
+            </a:solidFill>
           </a:ln>
         </p:spPr>
         <p:style>
@@ -12069,7 +12372,7 @@
             <a:pPr>
               <a:defRPr sz="950">
                 <a:solidFill>
-                  <a:srgbClr val="A0AEC0"/>
+                  <a:srgbClr val="475569"/>
                 </a:solidFill>
               </a:defRPr>
             </a:pPr>
@@ -12104,7 +12407,7 @@
             <a:pPr algn="r">
               <a:defRPr sz="1000" b="1">
                 <a:solidFill>
-                  <a:srgbClr val="38BDF8"/>
+                  <a:srgbClr val="0284C7"/>
                 </a:solidFill>
               </a:defRPr>
             </a:pPr>
@@ -12129,7 +12432,7 @@
             <a:avLst/>
           </a:prstGeom>
           <a:solidFill>
-            <a:srgbClr val="38BDF8"/>
+            <a:srgbClr val="0284C7"/>
           </a:solidFill>
           <a:ln>
             <a:noFill/>
@@ -12182,7 +12485,7 @@
             <a:pPr>
               <a:defRPr sz="900" b="1">
                 <a:solidFill>
-                  <a:srgbClr val="38BDF8"/>
+                  <a:srgbClr val="0284C7"/>
                 </a:solidFill>
               </a:defRPr>
             </a:pPr>
@@ -12197,7 +12500,7 @@
               </a:spcBef>
               <a:defRPr sz="2200" b="1">
                 <a:solidFill>
-                  <a:srgbClr val="F8FAFC"/>
+                  <a:srgbClr val="0F172A"/>
                 </a:solidFill>
               </a:defRPr>
             </a:pPr>
@@ -12212,7 +12515,7 @@
               </a:spcBef>
               <a:defRPr sz="1100">
                 <a:solidFill>
-                  <a:srgbClr val="A0AEC0"/>
+                  <a:srgbClr val="475569"/>
                 </a:solidFill>
               </a:defRPr>
             </a:pPr>
@@ -12237,11 +12540,11 @@
             <a:avLst/>
           </a:prstGeom>
           <a:solidFill>
-            <a:srgbClr val="131A2B"/>
+            <a:srgbClr val="FFFFFF"/>
           </a:solidFill>
           <a:ln w="12700">
             <a:solidFill>
-              <a:srgbClr val="222E4A"/>
+              <a:srgbClr val="E2E8F0"/>
             </a:solidFill>
           </a:ln>
         </p:spPr>
@@ -12282,7 +12585,7 @@
             <a:avLst/>
           </a:prstGeom>
           <a:solidFill>
-            <a:srgbClr val="38BDF8"/>
+            <a:srgbClr val="0284C7"/>
           </a:solidFill>
           <a:ln>
             <a:noFill/>
@@ -12335,7 +12638,7 @@
             <a:pPr>
               <a:defRPr sz="3200" b="1">
                 <a:solidFill>
-                  <a:srgbClr val="38BDF8"/>
+                  <a:srgbClr val="0284C7"/>
                 </a:solidFill>
               </a:defRPr>
             </a:pPr>
@@ -12350,7 +12653,7 @@
               </a:spcBef>
               <a:defRPr sz="900" b="1">
                 <a:solidFill>
-                  <a:srgbClr val="F8FAFC"/>
+                  <a:srgbClr val="0F172A"/>
                 </a:solidFill>
               </a:defRPr>
             </a:pPr>
@@ -12365,7 +12668,7 @@
               </a:spcBef>
               <a:defRPr sz="1000">
                 <a:solidFill>
-                  <a:srgbClr val="A0AEC0"/>
+                  <a:srgbClr val="475569"/>
                 </a:solidFill>
               </a:defRPr>
             </a:pPr>
@@ -12380,7 +12683,7 @@
               </a:spcBef>
               <a:defRPr sz="1000">
                 <a:solidFill>
-                  <a:srgbClr val="A0AEC0"/>
+                  <a:srgbClr val="475569"/>
                 </a:solidFill>
               </a:defRPr>
             </a:pPr>
@@ -12395,7 +12698,7 @@
               </a:spcBef>
               <a:defRPr sz="1000">
                 <a:solidFill>
-                  <a:srgbClr val="A0AEC0"/>
+                  <a:srgbClr val="475569"/>
                 </a:solidFill>
               </a:defRPr>
             </a:pPr>
@@ -12410,7 +12713,7 @@
               </a:spcBef>
               <a:defRPr sz="1000">
                 <a:solidFill>
-                  <a:srgbClr val="A0AEC0"/>
+                  <a:srgbClr val="475569"/>
                 </a:solidFill>
               </a:defRPr>
             </a:pPr>
@@ -12435,11 +12738,11 @@
             <a:avLst/>
           </a:prstGeom>
           <a:solidFill>
-            <a:srgbClr val="131A2B"/>
+            <a:srgbClr val="FFFFFF"/>
           </a:solidFill>
           <a:ln w="12700">
             <a:solidFill>
-              <a:srgbClr val="222E4A"/>
+              <a:srgbClr val="E2E8F0"/>
             </a:solidFill>
           </a:ln>
         </p:spPr>
@@ -12480,7 +12783,7 @@
             <a:avLst/>
           </a:prstGeom>
           <a:solidFill>
-            <a:srgbClr val="10B981"/>
+            <a:srgbClr val="059669"/>
           </a:solidFill>
           <a:ln>
             <a:noFill/>
@@ -12533,7 +12836,7 @@
             <a:pPr>
               <a:defRPr sz="3200" b="1">
                 <a:solidFill>
-                  <a:srgbClr val="10B981"/>
+                  <a:srgbClr val="059669"/>
                 </a:solidFill>
               </a:defRPr>
             </a:pPr>
@@ -12548,7 +12851,7 @@
               </a:spcBef>
               <a:defRPr sz="900" b="1">
                 <a:solidFill>
-                  <a:srgbClr val="F8FAFC"/>
+                  <a:srgbClr val="0F172A"/>
                 </a:solidFill>
               </a:defRPr>
             </a:pPr>
@@ -12563,7 +12866,7 @@
               </a:spcBef>
               <a:defRPr sz="1000">
                 <a:solidFill>
-                  <a:srgbClr val="A0AEC0"/>
+                  <a:srgbClr val="475569"/>
                 </a:solidFill>
               </a:defRPr>
             </a:pPr>
@@ -12578,12 +12881,12 @@
               </a:spcBef>
               <a:defRPr sz="1000">
                 <a:solidFill>
-                  <a:srgbClr val="A0AEC0"/>
-                </a:solidFill>
-              </a:defRPr>
-            </a:pPr>
-            <a:r>
-              <a:t>- Powers teachers' daily commute with 100% clean sunshine</a:t>
+                  <a:srgbClr val="475569"/>
+                </a:solidFill>
+              </a:defRPr>
+            </a:pPr>
+            <a:r>
+              <a:t>- Powers teachers' daily commute with clean sunshine</a:t>
             </a:r>
           </a:p>
           <a:p>
@@ -12593,7 +12896,7 @@
               </a:spcBef>
               <a:defRPr sz="1000">
                 <a:solidFill>
-                  <a:srgbClr val="A0AEC0"/>
+                  <a:srgbClr val="475569"/>
                 </a:solidFill>
               </a:defRPr>
             </a:pPr>
@@ -12608,7 +12911,7 @@
               </a:spcBef>
               <a:defRPr sz="1000">
                 <a:solidFill>
-                  <a:srgbClr val="A0AEC0"/>
+                  <a:srgbClr val="475569"/>
                 </a:solidFill>
               </a:defRPr>
             </a:pPr>
@@ -12633,11 +12936,11 @@
             <a:avLst/>
           </a:prstGeom>
           <a:solidFill>
-            <a:srgbClr val="131A2B"/>
+            <a:srgbClr val="FFFFFF"/>
           </a:solidFill>
           <a:ln w="12700">
             <a:solidFill>
-              <a:srgbClr val="222E4A"/>
+              <a:srgbClr val="E2E8F0"/>
             </a:solidFill>
           </a:ln>
         </p:spPr>
@@ -12678,7 +12981,7 @@
             <a:avLst/>
           </a:prstGeom>
           <a:solidFill>
-            <a:srgbClr val="F59E0B"/>
+            <a:srgbClr val="D97706"/>
           </a:solidFill>
           <a:ln>
             <a:noFill/>
@@ -12731,7 +13034,7 @@
             <a:pPr>
               <a:defRPr sz="3200" b="1">
                 <a:solidFill>
-                  <a:srgbClr val="F59E0B"/>
+                  <a:srgbClr val="D97706"/>
                 </a:solidFill>
               </a:defRPr>
             </a:pPr>
@@ -12746,7 +13049,7 @@
               </a:spcBef>
               <a:defRPr sz="900" b="1">
                 <a:solidFill>
-                  <a:srgbClr val="F8FAFC"/>
+                  <a:srgbClr val="0F172A"/>
                 </a:solidFill>
               </a:defRPr>
             </a:pPr>
@@ -12761,7 +13064,7 @@
               </a:spcBef>
               <a:defRPr sz="1000">
                 <a:solidFill>
-                  <a:srgbClr val="A0AEC0"/>
+                  <a:srgbClr val="475569"/>
                 </a:solidFill>
               </a:defRPr>
             </a:pPr>
@@ -12776,7 +13079,7 @@
               </a:spcBef>
               <a:defRPr sz="1000">
                 <a:solidFill>
-                  <a:srgbClr val="A0AEC0"/>
+                  <a:srgbClr val="475569"/>
                 </a:solidFill>
               </a:defRPr>
             </a:pPr>
@@ -12791,7 +13094,7 @@
               </a:spcBef>
               <a:defRPr sz="1000">
                 <a:solidFill>
-                  <a:srgbClr val="A0AEC0"/>
+                  <a:srgbClr val="475569"/>
                 </a:solidFill>
               </a:defRPr>
             </a:pPr>
@@ -12806,7 +13109,7 @@
               </a:spcBef>
               <a:defRPr sz="1000">
                 <a:solidFill>
-                  <a:srgbClr val="A0AEC0"/>
+                  <a:srgbClr val="475569"/>
                 </a:solidFill>
               </a:defRPr>
             </a:pPr>
@@ -12831,11 +13134,11 @@
             <a:avLst/>
           </a:prstGeom>
           <a:solidFill>
-            <a:srgbClr val="131A2B"/>
+            <a:srgbClr val="FFFFFF"/>
           </a:solidFill>
           <a:ln w="12700">
             <a:solidFill>
-              <a:srgbClr val="38BDF8"/>
+              <a:srgbClr val="0284C7"/>
             </a:solidFill>
           </a:ln>
         </p:spPr>
@@ -12886,7 +13189,7 @@
             <a:pPr>
               <a:defRPr sz="900" b="1">
                 <a:solidFill>
-                  <a:srgbClr val="38BDF8"/>
+                  <a:srgbClr val="0284C7"/>
                 </a:solidFill>
               </a:defRPr>
             </a:pPr>
@@ -12901,7 +13204,7 @@
               </a:spcBef>
               <a:defRPr sz="1050" b="1">
                 <a:solidFill>
-                  <a:srgbClr val="F8FAFC"/>
+                  <a:srgbClr val="0F172A"/>
                 </a:solidFill>
               </a:defRPr>
             </a:pPr>
@@ -12944,7 +13247,7 @@
             <a:avLst/>
           </a:prstGeom>
           <a:solidFill>
-            <a:srgbClr val="0B0F19"/>
+            <a:srgbClr val="F8FAFC"/>
           </a:solidFill>
           <a:ln>
             <a:noFill/>
@@ -12987,10 +13290,12 @@
             <a:avLst/>
           </a:prstGeom>
           <a:solidFill>
-            <a:srgbClr val="0F172A"/>
+            <a:srgbClr val="F1F5F9"/>
           </a:solidFill>
-          <a:ln>
-            <a:noFill/>
+          <a:ln w="12700">
+            <a:solidFill>
+              <a:srgbClr val="E2E8F0"/>
+            </a:solidFill>
           </a:ln>
         </p:spPr>
         <p:style>
@@ -13092,7 +13397,7 @@
             <a:pPr>
               <a:defRPr sz="950">
                 <a:solidFill>
-                  <a:srgbClr val="A0AEC0"/>
+                  <a:srgbClr val="475569"/>
                 </a:solidFill>
               </a:defRPr>
             </a:pPr>
@@ -13127,7 +13432,7 @@
             <a:pPr algn="r">
               <a:defRPr sz="1000" b="1">
                 <a:solidFill>
-                  <a:srgbClr val="38BDF8"/>
+                  <a:srgbClr val="0284C7"/>
                 </a:solidFill>
               </a:defRPr>
             </a:pPr>
@@ -13152,7 +13457,7 @@
             <a:avLst/>
           </a:prstGeom>
           <a:solidFill>
-            <a:srgbClr val="38BDF8"/>
+            <a:srgbClr val="0284C7"/>
           </a:solidFill>
           <a:ln>
             <a:noFill/>
@@ -13205,7 +13510,7 @@
             <a:pPr>
               <a:defRPr sz="900" b="1">
                 <a:solidFill>
-                  <a:srgbClr val="38BDF8"/>
+                  <a:srgbClr val="0284C7"/>
                 </a:solidFill>
               </a:defRPr>
             </a:pPr>
@@ -13220,7 +13525,7 @@
               </a:spcBef>
               <a:defRPr sz="2200" b="1">
                 <a:solidFill>
-                  <a:srgbClr val="F8FAFC"/>
+                  <a:srgbClr val="0F172A"/>
                 </a:solidFill>
               </a:defRPr>
             </a:pPr>
@@ -13235,7 +13540,7 @@
               </a:spcBef>
               <a:defRPr sz="1100">
                 <a:solidFill>
-                  <a:srgbClr val="A0AEC0"/>
+                  <a:srgbClr val="475569"/>
                 </a:solidFill>
               </a:defRPr>
             </a:pPr>
@@ -13260,11 +13565,11 @@
             <a:avLst/>
           </a:prstGeom>
           <a:solidFill>
-            <a:srgbClr val="131A2B"/>
+            <a:srgbClr val="FFFFFF"/>
           </a:solidFill>
           <a:ln w="12700">
             <a:solidFill>
-              <a:srgbClr val="222E4A"/>
+              <a:srgbClr val="E2E8F0"/>
             </a:solidFill>
           </a:ln>
         </p:spPr>
@@ -13305,7 +13610,7 @@
             <a:avLst/>
           </a:prstGeom>
           <a:solidFill>
-            <a:srgbClr val="38BDF8"/>
+            <a:srgbClr val="0284C7"/>
           </a:solidFill>
           <a:ln>
             <a:noFill/>
@@ -13356,9 +13661,9 @@
           <a:lstStyle/>
           <a:p>
             <a:pPr>
-              <a:defRPr sz="2600" b="1">
-                <a:solidFill>
-                  <a:srgbClr val="38BDF8"/>
+              <a:defRPr sz="2400" b="1">
+                <a:solidFill>
+                  <a:srgbClr val="0284C7"/>
                 </a:solidFill>
               </a:defRPr>
             </a:pPr>
@@ -13373,7 +13678,7 @@
               </a:spcBef>
               <a:defRPr sz="900" b="1">
                 <a:solidFill>
-                  <a:srgbClr val="F8FAFC"/>
+                  <a:srgbClr val="0F172A"/>
                 </a:solidFill>
               </a:defRPr>
             </a:pPr>
@@ -13388,7 +13693,7 @@
               </a:spcBef>
               <a:defRPr sz="1000">
                 <a:solidFill>
-                  <a:srgbClr val="A0AEC0"/>
+                  <a:srgbClr val="475569"/>
                 </a:solidFill>
               </a:defRPr>
             </a:pPr>
@@ -13403,7 +13708,7 @@
               </a:spcBef>
               <a:defRPr sz="1000">
                 <a:solidFill>
-                  <a:srgbClr val="A0AEC0"/>
+                  <a:srgbClr val="475569"/>
                 </a:solidFill>
               </a:defRPr>
             </a:pPr>
@@ -13418,7 +13723,7 @@
               </a:spcBef>
               <a:defRPr sz="1000">
                 <a:solidFill>
-                  <a:srgbClr val="A0AEC0"/>
+                  <a:srgbClr val="475569"/>
                 </a:solidFill>
               </a:defRPr>
             </a:pPr>
@@ -13433,7 +13738,7 @@
               </a:spcBef>
               <a:defRPr sz="1000">
                 <a:solidFill>
-                  <a:srgbClr val="A0AEC0"/>
+                  <a:srgbClr val="475569"/>
                 </a:solidFill>
               </a:defRPr>
             </a:pPr>
@@ -13458,11 +13763,11 @@
             <a:avLst/>
           </a:prstGeom>
           <a:solidFill>
-            <a:srgbClr val="131A2B"/>
+            <a:srgbClr val="FFFFFF"/>
           </a:solidFill>
           <a:ln w="12700">
             <a:solidFill>
-              <a:srgbClr val="222E4A"/>
+              <a:srgbClr val="E2E8F0"/>
             </a:solidFill>
           </a:ln>
         </p:spPr>
@@ -13503,7 +13808,7 @@
             <a:avLst/>
           </a:prstGeom>
           <a:solidFill>
-            <a:srgbClr val="10B981"/>
+            <a:srgbClr val="059669"/>
           </a:solidFill>
           <a:ln>
             <a:noFill/>
@@ -13554,9 +13859,9 @@
           <a:lstStyle/>
           <a:p>
             <a:pPr>
-              <a:defRPr sz="2600" b="1">
-                <a:solidFill>
-                  <a:srgbClr val="10B981"/>
+              <a:defRPr sz="2400" b="1">
+                <a:solidFill>
+                  <a:srgbClr val="059669"/>
                 </a:solidFill>
               </a:defRPr>
             </a:pPr>
@@ -13571,7 +13876,7 @@
               </a:spcBef>
               <a:defRPr sz="900" b="1">
                 <a:solidFill>
-                  <a:srgbClr val="F8FAFC"/>
+                  <a:srgbClr val="0F172A"/>
                 </a:solidFill>
               </a:defRPr>
             </a:pPr>
@@ -13586,7 +13891,7 @@
               </a:spcBef>
               <a:defRPr sz="1000">
                 <a:solidFill>
-                  <a:srgbClr val="A0AEC0"/>
+                  <a:srgbClr val="475569"/>
                 </a:solidFill>
               </a:defRPr>
             </a:pPr>
@@ -13601,7 +13906,7 @@
               </a:spcBef>
               <a:defRPr sz="1000">
                 <a:solidFill>
-                  <a:srgbClr val="A0AEC0"/>
+                  <a:srgbClr val="475569"/>
                 </a:solidFill>
               </a:defRPr>
             </a:pPr>
@@ -13616,7 +13921,7 @@
               </a:spcBef>
               <a:defRPr sz="1000">
                 <a:solidFill>
-                  <a:srgbClr val="A0AEC0"/>
+                  <a:srgbClr val="475569"/>
                 </a:solidFill>
               </a:defRPr>
             </a:pPr>
@@ -13631,7 +13936,7 @@
               </a:spcBef>
               <a:defRPr sz="1000">
                 <a:solidFill>
-                  <a:srgbClr val="A0AEC0"/>
+                  <a:srgbClr val="475569"/>
                 </a:solidFill>
               </a:defRPr>
             </a:pPr>
@@ -13656,11 +13961,11 @@
             <a:avLst/>
           </a:prstGeom>
           <a:solidFill>
-            <a:srgbClr val="131A2B"/>
+            <a:srgbClr val="FFFFFF"/>
           </a:solidFill>
           <a:ln w="12700">
             <a:solidFill>
-              <a:srgbClr val="222E4A"/>
+              <a:srgbClr val="E2E8F0"/>
             </a:solidFill>
           </a:ln>
         </p:spPr>
@@ -13701,7 +14006,7 @@
             <a:avLst/>
           </a:prstGeom>
           <a:solidFill>
-            <a:srgbClr val="F59E0B"/>
+            <a:srgbClr val="D97706"/>
           </a:solidFill>
           <a:ln>
             <a:noFill/>
@@ -13752,9 +14057,9 @@
           <a:lstStyle/>
           <a:p>
             <a:pPr>
-              <a:defRPr sz="2600" b="1">
-                <a:solidFill>
-                  <a:srgbClr val="F59E0B"/>
+              <a:defRPr sz="2400" b="1">
+                <a:solidFill>
+                  <a:srgbClr val="D97706"/>
                 </a:solidFill>
               </a:defRPr>
             </a:pPr>
@@ -13769,7 +14074,7 @@
               </a:spcBef>
               <a:defRPr sz="900" b="1">
                 <a:solidFill>
-                  <a:srgbClr val="F8FAFC"/>
+                  <a:srgbClr val="0F172A"/>
                 </a:solidFill>
               </a:defRPr>
             </a:pPr>
@@ -13784,7 +14089,7 @@
               </a:spcBef>
               <a:defRPr sz="1000">
                 <a:solidFill>
-                  <a:srgbClr val="A0AEC0"/>
+                  <a:srgbClr val="475569"/>
                 </a:solidFill>
               </a:defRPr>
             </a:pPr>
@@ -13799,7 +14104,7 @@
               </a:spcBef>
               <a:defRPr sz="1000">
                 <a:solidFill>
-                  <a:srgbClr val="A0AEC0"/>
+                  <a:srgbClr val="475569"/>
                 </a:solidFill>
               </a:defRPr>
             </a:pPr>
@@ -13814,7 +14119,7 @@
               </a:spcBef>
               <a:defRPr sz="1000">
                 <a:solidFill>
-                  <a:srgbClr val="A0AEC0"/>
+                  <a:srgbClr val="475569"/>
                 </a:solidFill>
               </a:defRPr>
             </a:pPr>
@@ -13829,7 +14134,7 @@
               </a:spcBef>
               <a:defRPr sz="1000">
                 <a:solidFill>
-                  <a:srgbClr val="A0AEC0"/>
+                  <a:srgbClr val="475569"/>
                 </a:solidFill>
               </a:defRPr>
             </a:pPr>
@@ -13854,11 +14159,11 @@
             <a:avLst/>
           </a:prstGeom>
           <a:solidFill>
-            <a:srgbClr val="131A2B"/>
+            <a:srgbClr val="FFFFFF"/>
           </a:solidFill>
           <a:ln w="12700">
             <a:solidFill>
-              <a:srgbClr val="10B981"/>
+              <a:srgbClr val="059669"/>
             </a:solidFill>
           </a:ln>
         </p:spPr>
@@ -13909,7 +14214,7 @@
             <a:pPr>
               <a:defRPr sz="900" b="1">
                 <a:solidFill>
-                  <a:srgbClr val="10B981"/>
+                  <a:srgbClr val="059669"/>
                 </a:solidFill>
               </a:defRPr>
             </a:pPr>
@@ -13924,7 +14229,7 @@
               </a:spcBef>
               <a:defRPr sz="1050" b="1">
                 <a:solidFill>
-                  <a:srgbClr val="F8FAFC"/>
+                  <a:srgbClr val="0F172A"/>
                 </a:solidFill>
               </a:defRPr>
             </a:pPr>

</xml_diff>